<commit_message>
Apply Desjardins theme, Lucide icons, and expand Outlook episode.
Redesign the generator with corporate green styling, professional Lucide glyphs instead of emojis, and cleaner footers without logo lockups. Add Outlook tips for project status and weekly planning, fully French copy, and regenerate all episode decks.

Co-authored-by: Cursor <cursoragent@cursor.com>
</commit_message>
<xml_diff>
--- a/presentations/La_Minute_Copilot_Personas.pptx
+++ b/presentations/La_Minute_Copilot_Personas.pptx
@@ -3859,7 +3859,7 @@
     <p:bg>
       <p:bgPr>
         <a:solidFill>
-          <a:srgbClr val="0078D4"/>
+          <a:srgbClr val="E6F0EA"/>
         </a:solidFill>
         <a:effectLst/>
       </p:bgPr>
@@ -3873,14 +3873,58 @@
       <p:grpSpPr/>
       <p:sp>
         <p:nvSpPr>
-          <p:cNvPr id="2" name="TextBox 1"/>
+          <p:cNvPr id="2" name="Rectangle 1"/>
+          <p:cNvSpPr/>
+          <p:nvPr/>
+        </p:nvSpPr>
+        <p:spPr>
+          <a:xfrm>
+            <a:off x="0" y="0"/>
+            <a:ext cx="6766560" cy="6858000"/>
+          </a:xfrm>
+          <a:prstGeom prst="rect">
+            <a:avLst/>
+          </a:prstGeom>
+          <a:solidFill>
+            <a:srgbClr val="00874E"/>
+          </a:solidFill>
+          <a:ln>
+            <a:noFill/>
+          </a:ln>
+          <a:effectLst/>
+        </p:spPr>
+        <p:style>
+          <a:lnRef idx="1">
+            <a:schemeClr val="accent1"/>
+          </a:lnRef>
+          <a:fillRef idx="3">
+            <a:schemeClr val="accent1"/>
+          </a:fillRef>
+          <a:effectRef idx="2">
+            <a:schemeClr val="accent1"/>
+          </a:effectRef>
+          <a:fontRef idx="minor">
+            <a:schemeClr val="lt1"/>
+          </a:fontRef>
+        </p:style>
+        <p:txBody>
+          <a:bodyPr rtlCol="0" anchor="ctr"/>
+          <a:lstStyle/>
+          <a:p>
+            <a:pPr algn="ctr"/>
+          </a:p>
+        </p:txBody>
+      </p:sp>
+      <p:sp>
+        <p:nvSpPr>
+          <p:cNvPr id="3" name="TextBox 2"/>
           <p:cNvSpPr txBox="1"/>
           <p:nvPr/>
         </p:nvSpPr>
         <p:spPr>
           <a:xfrm>
-            <a:off x="914400" y="1828800"/>
-            <a:ext cx="10058400" cy="1097280"/>
+            <a:off x="640080" y="1828800"/>
+            <a:ext cx="5669280" cy="1463040"/>
           </a:xfrm>
           <a:prstGeom prst="rect">
             <a:avLst/>
@@ -3888,13 +3932,13 @@
           <a:noFill/>
         </p:spPr>
         <p:txBody>
-          <a:bodyPr wrap="square">
+          <a:bodyPr wrap="square" lIns="45720" rIns="45720" tIns="18288" bIns="18288">
             <a:spAutoFit/>
           </a:bodyPr>
           <a:lstStyle/>
           <a:p>
-            <a:pPr algn="ctr">
-              <a:defRPr sz="4800" b="1">
+            <a:pPr algn="l">
+              <a:defRPr sz="4400" b="1">
                 <a:solidFill>
                   <a:srgbClr val="FFFFFF"/>
                 </a:solidFill>
@@ -3902,21 +3946,65 @@
               </a:defRPr>
             </a:pPr>
             <a:r>
-              <a:t>🤖 La minute Copilot</a:t>
-            </a:r>
-          </a:p>
-        </p:txBody>
-      </p:sp>
-      <p:sp>
-        <p:nvSpPr>
-          <p:cNvPr id="3" name="TextBox 2"/>
+              <a:t>La minute Copilot</a:t>
+            </a:r>
+          </a:p>
+        </p:txBody>
+      </p:sp>
+      <p:sp>
+        <p:nvSpPr>
+          <p:cNvPr id="4" name="Rectangle 3"/>
+          <p:cNvSpPr/>
+          <p:nvPr/>
+        </p:nvSpPr>
+        <p:spPr>
+          <a:xfrm>
+            <a:off x="640080" y="3246120"/>
+            <a:ext cx="2926080" cy="36576"/>
+          </a:xfrm>
+          <a:prstGeom prst="rect">
+            <a:avLst/>
+          </a:prstGeom>
+          <a:solidFill>
+            <a:srgbClr val="FFFFFF"/>
+          </a:solidFill>
+          <a:ln>
+            <a:noFill/>
+          </a:ln>
+          <a:effectLst/>
+        </p:spPr>
+        <p:style>
+          <a:lnRef idx="1">
+            <a:schemeClr val="accent1"/>
+          </a:lnRef>
+          <a:fillRef idx="3">
+            <a:schemeClr val="accent1"/>
+          </a:fillRef>
+          <a:effectRef idx="2">
+            <a:schemeClr val="accent1"/>
+          </a:effectRef>
+          <a:fontRef idx="minor">
+            <a:schemeClr val="lt1"/>
+          </a:fontRef>
+        </p:style>
+        <p:txBody>
+          <a:bodyPr rtlCol="0" anchor="ctr"/>
+          <a:lstStyle/>
+          <a:p>
+            <a:pPr algn="ctr"/>
+          </a:p>
+        </p:txBody>
+      </p:sp>
+      <p:sp>
+        <p:nvSpPr>
+          <p:cNvPr id="5" name="TextBox 4"/>
           <p:cNvSpPr txBox="1"/>
           <p:nvPr/>
         </p:nvSpPr>
         <p:spPr>
           <a:xfrm>
-            <a:off x="914400" y="2926080"/>
-            <a:ext cx="10058400" cy="731520"/>
+            <a:off x="640080" y="3429000"/>
+            <a:ext cx="5669280" cy="640080"/>
           </a:xfrm>
           <a:prstGeom prst="rect">
             <a:avLst/>
@@ -3924,35 +4012,35 @@
           <a:noFill/>
         </p:spPr>
         <p:txBody>
-          <a:bodyPr wrap="square">
+          <a:bodyPr wrap="square" lIns="45720" rIns="45720" tIns="18288" bIns="18288">
             <a:spAutoFit/>
           </a:bodyPr>
           <a:lstStyle/>
           <a:p>
-            <a:pPr algn="ctr">
-              <a:defRPr sz="2800" b="0">
-                <a:solidFill>
-                  <a:srgbClr val="AAD4F0"/>
+            <a:pPr algn="l">
+              <a:defRPr sz="2200" b="0">
+                <a:solidFill>
+                  <a:srgbClr val="FFFFFF"/>
                 </a:solidFill>
                 <a:latin typeface="Calibri"/>
               </a:defRPr>
             </a:pPr>
             <a:r>
-              <a:t>🎭 L'importance des personas dans les prompts</a:t>
-            </a:r>
-          </a:p>
-        </p:txBody>
-      </p:sp>
-      <p:sp>
-        <p:nvSpPr>
-          <p:cNvPr id="4" name="TextBox 3"/>
+              <a:t>L'importance des personas dans les prompts</a:t>
+            </a:r>
+          </a:p>
+        </p:txBody>
+      </p:sp>
+      <p:sp>
+        <p:nvSpPr>
+          <p:cNvPr id="6" name="TextBox 5"/>
           <p:cNvSpPr txBox="1"/>
           <p:nvPr/>
         </p:nvSpPr>
         <p:spPr>
           <a:xfrm>
-            <a:off x="914400" y="4114800"/>
-            <a:ext cx="10058400" cy="548640"/>
+            <a:off x="640080" y="4572000"/>
+            <a:ext cx="5669280" cy="365760"/>
           </a:xfrm>
           <a:prstGeom prst="rect">
             <a:avLst/>
@@ -3960,15 +4048,15 @@
           <a:noFill/>
         </p:spPr>
         <p:txBody>
-          <a:bodyPr wrap="square">
+          <a:bodyPr wrap="square" lIns="45720" rIns="45720" tIns="18288" bIns="18288">
             <a:spAutoFit/>
           </a:bodyPr>
           <a:lstStyle/>
           <a:p>
-            <a:pPr algn="ctr">
-              <a:defRPr sz="1600" b="0">
-                <a:solidFill>
-                  <a:srgbClr val="AAD4F0"/>
+            <a:pPr algn="l">
+              <a:defRPr sz="1300" b="0">
+                <a:solidFill>
+                  <a:srgbClr val="CCE0D2"/>
                 </a:solidFill>
                 <a:latin typeface="Calibri"/>
               </a:defRPr>
@@ -3993,7 +4081,7 @@
     <p:bg>
       <p:bgPr>
         <a:solidFill>
-          <a:srgbClr val="FFFFFF"/>
+          <a:srgbClr val="E6F0EA"/>
         </a:solidFill>
         <a:effectLst/>
       </p:bgPr>
@@ -4013,8 +4101,8 @@
         </p:nvSpPr>
         <p:spPr>
           <a:xfrm>
-            <a:off x="457200" y="274320"/>
-            <a:ext cx="10972800" cy="640080"/>
+            <a:off x="457200" y="365760"/>
+            <a:ext cx="10972800" cy="731520"/>
           </a:xfrm>
           <a:prstGeom prst="rect">
             <a:avLst/>
@@ -4022,21 +4110,21 @@
           <a:noFill/>
         </p:spPr>
         <p:txBody>
-          <a:bodyPr wrap="square">
+          <a:bodyPr wrap="square" lIns="45720" rIns="45720" tIns="18288" bIns="18288">
             <a:spAutoFit/>
           </a:bodyPr>
           <a:lstStyle/>
           <a:p>
             <a:pPr algn="l">
-              <a:defRPr sz="3200" b="1">
-                <a:solidFill>
-                  <a:srgbClr val="2B2B2B"/>
+              <a:defRPr sz="2800" b="1">
+                <a:solidFill>
+                  <a:srgbClr val="006B3F"/>
                 </a:solidFill>
                 <a:latin typeface="Calibri"/>
               </a:defRPr>
             </a:pPr>
             <a:r>
-              <a:t>🎭 Qu'est-ce qu'un persona?</a:t>
+              <a:t>Qu'est-ce qu'un persona?</a:t>
             </a:r>
           </a:p>
         </p:txBody>
@@ -4049,8 +4137,8 @@
         </p:nvSpPr>
         <p:spPr>
           <a:xfrm>
-            <a:off x="457200" y="914400"/>
-            <a:ext cx="10972800" cy="457200"/>
+            <a:off x="457200" y="1005840"/>
+            <a:ext cx="10972800" cy="411480"/>
           </a:xfrm>
           <a:prstGeom prst="rect">
             <a:avLst/>
@@ -4058,13 +4146,13 @@
           <a:noFill/>
         </p:spPr>
         <p:txBody>
-          <a:bodyPr wrap="square">
+          <a:bodyPr wrap="square" lIns="45720" rIns="45720" tIns="18288" bIns="18288">
             <a:spAutoFit/>
           </a:bodyPr>
           <a:lstStyle/>
           <a:p>
             <a:pPr algn="l">
-              <a:defRPr sz="1800" b="0">
+              <a:defRPr sz="1500" b="0">
                 <a:solidFill>
                   <a:srgbClr val="6B6B6B"/>
                 </a:solidFill>
@@ -4079,113 +4167,25 @@
       </p:sp>
       <p:sp>
         <p:nvSpPr>
-          <p:cNvPr id="4" name="TextBox 3"/>
-          <p:cNvSpPr txBox="1"/>
-          <p:nvPr/>
-        </p:nvSpPr>
-        <p:spPr>
-          <a:xfrm>
-            <a:off x="457200" y="1554480"/>
-            <a:ext cx="10972800" cy="1371600"/>
-          </a:xfrm>
-          <a:prstGeom prst="rect">
-            <a:avLst/>
-          </a:prstGeom>
-          <a:noFill/>
-        </p:spPr>
-        <p:txBody>
-          <a:bodyPr wrap="square">
-            <a:spAutoFit/>
-          </a:bodyPr>
-          <a:lstStyle/>
-          <a:p>
-            <a:pPr>
-              <a:spcAft>
-                <a:spcPts val="400"/>
-              </a:spcAft>
-              <a:defRPr sz="1400">
-                <a:solidFill>
-                  <a:srgbClr val="2B2B2B"/>
-                </a:solidFill>
-                <a:latin typeface="Calibri"/>
-              </a:defRPr>
-            </a:pPr>
-            <a:r>
-              <a:t>• Un persona = un rôle + un contexte + un ton</a:t>
-            </a:r>
-          </a:p>
-          <a:p>
-            <a:pPr>
-              <a:spcAft>
-                <a:spcPts val="400"/>
-              </a:spcAft>
-              <a:defRPr sz="1400">
-                <a:solidFill>
-                  <a:srgbClr val="2B2B2B"/>
-                </a:solidFill>
-                <a:latin typeface="Calibri"/>
-              </a:defRPr>
-            </a:pPr>
-            <a:r>
-              <a:t>• Copilot adapte sa réponse selon le persona donné</a:t>
-            </a:r>
-          </a:p>
-          <a:p>
-            <a:pPr>
-              <a:spcAft>
-                <a:spcPts val="400"/>
-              </a:spcAft>
-              <a:defRPr sz="1400">
-                <a:solidFill>
-                  <a:srgbClr val="2B2B2B"/>
-                </a:solidFill>
-                <a:latin typeface="Calibri"/>
-              </a:defRPr>
-            </a:pPr>
-            <a:r>
-              <a:t>• Sans persona: réponse générique et moyenne</a:t>
-            </a:r>
-          </a:p>
-          <a:p>
-            <a:pPr>
-              <a:spcAft>
-                <a:spcPts val="400"/>
-              </a:spcAft>
-              <a:defRPr sz="1400">
-                <a:solidFill>
-                  <a:srgbClr val="2B2B2B"/>
-                </a:solidFill>
-                <a:latin typeface="Calibri"/>
-              </a:defRPr>
-            </a:pPr>
-            <a:r>
-              <a:t>• Avec persona: réponse experte et ciblée</a:t>
-            </a:r>
-          </a:p>
-        </p:txBody>
-      </p:sp>
-      <p:sp>
-        <p:nvSpPr>
-          <p:cNvPr id="5" name="Rectangle 4"/>
+          <p:cNvPr id="4" name="Rectangle 3"/>
           <p:cNvSpPr/>
           <p:nvPr/>
         </p:nvSpPr>
         <p:spPr>
           <a:xfrm>
-            <a:off x="457200" y="3017520"/>
-            <a:ext cx="5212080" cy="3657600"/>
+            <a:off x="457200" y="1508760"/>
+            <a:ext cx="11274552" cy="18288"/>
           </a:xfrm>
           <a:prstGeom prst="rect">
             <a:avLst/>
           </a:prstGeom>
           <a:solidFill>
-            <a:srgbClr val="FFFFFF"/>
+            <a:srgbClr val="00874E"/>
           </a:solidFill>
           <a:ln>
-            <a:solidFill>
-              <a:srgbClr val="E0E0E0"/>
-            </a:solidFill>
+            <a:noFill/>
           </a:ln>
+          <a:effectLst/>
         </p:spPr>
         <p:style>
           <a:lnRef idx="1">
@@ -4211,50 +4211,14 @@
       </p:sp>
       <p:sp>
         <p:nvSpPr>
-          <p:cNvPr id="6" name="TextBox 5"/>
+          <p:cNvPr id="5" name="TextBox 4"/>
           <p:cNvSpPr txBox="1"/>
           <p:nvPr/>
         </p:nvSpPr>
         <p:spPr>
           <a:xfrm>
-            <a:off x="731520" y="3200400"/>
-            <a:ext cx="4663440" cy="457200"/>
-          </a:xfrm>
-          <a:prstGeom prst="rect">
-            <a:avLst/>
-          </a:prstGeom>
-          <a:noFill/>
-        </p:spPr>
-        <p:txBody>
-          <a:bodyPr wrap="square">
-            <a:spAutoFit/>
-          </a:bodyPr>
-          <a:lstStyle/>
-          <a:p>
-            <a:pPr algn="l">
-              <a:defRPr sz="1800" b="1">
-                <a:solidFill>
-                  <a:srgbClr val="EF4444"/>
-                </a:solidFill>
-                <a:latin typeface="Calibri"/>
-              </a:defRPr>
-            </a:pPr>
-            <a:r>
-              <a:t>❌ Sans persona (moyen)</a:t>
-            </a:r>
-          </a:p>
-        </p:txBody>
-      </p:sp>
-      <p:sp>
-        <p:nvSpPr>
-          <p:cNvPr id="7" name="TextBox 6"/>
-          <p:cNvSpPr txBox="1"/>
-          <p:nvPr/>
-        </p:nvSpPr>
-        <p:spPr>
-          <a:xfrm>
-            <a:off x="731520" y="3657600"/>
-            <a:ext cx="4663440" cy="2743200"/>
+            <a:off x="457200" y="1737360"/>
+            <a:ext cx="10972800" cy="1188720"/>
           </a:xfrm>
           <a:prstGeom prst="rect">
             <a:avLst/>
@@ -4271,7 +4235,7 @@
               <a:spcAft>
                 <a:spcPts val="400"/>
               </a:spcAft>
-              <a:defRPr sz="1300">
+              <a:defRPr sz="1400">
                 <a:solidFill>
                   <a:srgbClr val="2B2B2B"/>
                 </a:solidFill>
@@ -4279,7 +4243,7 @@
               </a:defRPr>
             </a:pPr>
             <a:r>
-              <a:t>«Rédige un courriel de suivi»</a:t>
+              <a:t>• Un persona = un rôle + un contexte + un ton</a:t>
             </a:r>
           </a:p>
           <a:p>
@@ -4287,20 +4251,23 @@
               <a:spcAft>
                 <a:spcPts val="400"/>
               </a:spcAft>
-              <a:defRPr sz="1300">
+              <a:defRPr sz="1400">
                 <a:solidFill>
                   <a:srgbClr val="2B2B2B"/>
                 </a:solidFill>
                 <a:latin typeface="Calibri"/>
               </a:defRPr>
             </a:pPr>
+            <a:r>
+              <a:t>• Copilot adapte sa réponse selon le persona donné</a:t>
+            </a:r>
           </a:p>
           <a:p>
             <a:pPr>
               <a:spcAft>
                 <a:spcPts val="400"/>
               </a:spcAft>
-              <a:defRPr sz="1300">
+              <a:defRPr sz="1400">
                 <a:solidFill>
                   <a:srgbClr val="2B2B2B"/>
                 </a:solidFill>
@@ -4308,21 +4275,37 @@
               </a:defRPr>
             </a:pPr>
             <a:r>
-              <a:t>→ Réponse générique, sans personnalité, applicable à personne</a:t>
-            </a:r>
-          </a:p>
-        </p:txBody>
-      </p:sp>
-      <p:sp>
-        <p:nvSpPr>
-          <p:cNvPr id="8" name="Rectangle 7"/>
+              <a:t>• Sans persona: réponse générique et moyenne</a:t>
+            </a:r>
+          </a:p>
+          <a:p>
+            <a:pPr>
+              <a:spcAft>
+                <a:spcPts val="400"/>
+              </a:spcAft>
+              <a:defRPr sz="1400">
+                <a:solidFill>
+                  <a:srgbClr val="2B2B2B"/>
+                </a:solidFill>
+                <a:latin typeface="Calibri"/>
+              </a:defRPr>
+            </a:pPr>
+            <a:r>
+              <a:t>• Avec persona: réponse experte et ciblée</a:t>
+            </a:r>
+          </a:p>
+        </p:txBody>
+      </p:sp>
+      <p:sp>
+        <p:nvSpPr>
+          <p:cNvPr id="6" name="Rectangle 5"/>
           <p:cNvSpPr/>
           <p:nvPr/>
         </p:nvSpPr>
         <p:spPr>
           <a:xfrm>
-            <a:off x="5943600" y="3017520"/>
-            <a:ext cx="5212080" cy="3657600"/>
+            <a:off x="457200" y="2926080"/>
+            <a:ext cx="5212080" cy="3291840"/>
           </a:xfrm>
           <a:prstGeom prst="rect">
             <a:avLst/>
@@ -4335,6 +4318,7 @@
               <a:srgbClr val="E0E0E0"/>
             </a:solidFill>
           </a:ln>
+          <a:effectLst/>
         </p:spPr>
         <p:style>
           <a:lnRef idx="1">
@@ -4358,6 +4342,66 @@
           </a:p>
         </p:txBody>
       </p:sp>
+      <p:pic>
+        <p:nvPicPr>
+          <p:cNvPr id="7" name="Picture 6" descr="circle-x_EF4444_30.png"/>
+          <p:cNvPicPr>
+            <a:picLocks noChangeAspect="1"/>
+          </p:cNvPicPr>
+          <p:nvPr/>
+        </p:nvPicPr>
+        <p:blipFill>
+          <a:blip r:embed="rId3"/>
+          <a:stretch>
+            <a:fillRect/>
+          </a:stretch>
+        </p:blipFill>
+        <p:spPr>
+          <a:xfrm>
+            <a:off x="713232" y="3090672"/>
+            <a:ext cx="292608" cy="292608"/>
+          </a:xfrm>
+          <a:prstGeom prst="rect">
+            <a:avLst/>
+          </a:prstGeom>
+        </p:spPr>
+      </p:pic>
+      <p:sp>
+        <p:nvSpPr>
+          <p:cNvPr id="8" name="TextBox 7"/>
+          <p:cNvSpPr txBox="1"/>
+          <p:nvPr/>
+        </p:nvSpPr>
+        <p:spPr>
+          <a:xfrm>
+            <a:off x="1115568" y="3108960"/>
+            <a:ext cx="4370832" cy="457200"/>
+          </a:xfrm>
+          <a:prstGeom prst="rect">
+            <a:avLst/>
+          </a:prstGeom>
+          <a:noFill/>
+        </p:spPr>
+        <p:txBody>
+          <a:bodyPr wrap="square" lIns="45720" rIns="45720" tIns="18288" bIns="18288">
+            <a:spAutoFit/>
+          </a:bodyPr>
+          <a:lstStyle/>
+          <a:p>
+            <a:pPr algn="l">
+              <a:defRPr sz="1700" b="1">
+                <a:solidFill>
+                  <a:srgbClr val="EF4444"/>
+                </a:solidFill>
+                <a:latin typeface="Calibri"/>
+              </a:defRPr>
+            </a:pPr>
+            <a:r>
+              <a:t>Sans persona (moyen)</a:t>
+            </a:r>
+          </a:p>
+        </p:txBody>
+      </p:sp>
       <p:sp>
         <p:nvSpPr>
           <p:cNvPr id="9" name="TextBox 8"/>
@@ -4366,44 +4410,8 @@
         </p:nvSpPr>
         <p:spPr>
           <a:xfrm>
-            <a:off x="6217920" y="3200400"/>
-            <a:ext cx="4663440" cy="457200"/>
-          </a:xfrm>
-          <a:prstGeom prst="rect">
-            <a:avLst/>
-          </a:prstGeom>
-          <a:noFill/>
-        </p:spPr>
-        <p:txBody>
-          <a:bodyPr wrap="square">
-            <a:spAutoFit/>
-          </a:bodyPr>
-          <a:lstStyle/>
-          <a:p>
-            <a:pPr algn="l">
-              <a:defRPr sz="1800" b="1">
-                <a:solidFill>
-                  <a:srgbClr val="10B981"/>
-                </a:solidFill>
-                <a:latin typeface="Calibri"/>
-              </a:defRPr>
-            </a:pPr>
-            <a:r>
-              <a:t>✅ Avec persona (puissant)</a:t>
-            </a:r>
-          </a:p>
-        </p:txBody>
-      </p:sp>
-      <p:sp>
-        <p:nvSpPr>
-          <p:cNvPr id="10" name="TextBox 9"/>
-          <p:cNvSpPr txBox="1"/>
-          <p:nvPr/>
-        </p:nvSpPr>
-        <p:spPr>
-          <a:xfrm>
-            <a:off x="6217920" y="3657600"/>
-            <a:ext cx="4663440" cy="2743200"/>
+            <a:off x="731520" y="3703320"/>
+            <a:ext cx="4663440" cy="2331720"/>
           </a:xfrm>
           <a:prstGeom prst="rect">
             <a:avLst/>
@@ -4428,7 +4436,7 @@
               </a:defRPr>
             </a:pPr>
             <a:r>
-              <a:t>«En tant que chef de projet senior, rédige un courriel de suivi technique»</a:t>
+              <a:t>«Rédige un courriel de suivi»</a:t>
             </a:r>
           </a:p>
           <a:p>
@@ -4457,7 +4465,297 @@
               </a:defRPr>
             </a:pPr>
             <a:r>
+              <a:t>→ Réponse générique, sans personnalité, applicable à personne</a:t>
+            </a:r>
+          </a:p>
+        </p:txBody>
+      </p:sp>
+      <p:sp>
+        <p:nvSpPr>
+          <p:cNvPr id="10" name="Rectangle 9"/>
+          <p:cNvSpPr/>
+          <p:nvPr/>
+        </p:nvSpPr>
+        <p:spPr>
+          <a:xfrm>
+            <a:off x="5943600" y="2926080"/>
+            <a:ext cx="5212080" cy="3291840"/>
+          </a:xfrm>
+          <a:prstGeom prst="rect">
+            <a:avLst/>
+          </a:prstGeom>
+          <a:solidFill>
+            <a:srgbClr val="FFFFFF"/>
+          </a:solidFill>
+          <a:ln>
+            <a:solidFill>
+              <a:srgbClr val="E0E0E0"/>
+            </a:solidFill>
+          </a:ln>
+          <a:effectLst/>
+        </p:spPr>
+        <p:style>
+          <a:lnRef idx="1">
+            <a:schemeClr val="accent1"/>
+          </a:lnRef>
+          <a:fillRef idx="3">
+            <a:schemeClr val="accent1"/>
+          </a:fillRef>
+          <a:effectRef idx="2">
+            <a:schemeClr val="accent1"/>
+          </a:effectRef>
+          <a:fontRef idx="minor">
+            <a:schemeClr val="lt1"/>
+          </a:fontRef>
+        </p:style>
+        <p:txBody>
+          <a:bodyPr rtlCol="0" anchor="ctr"/>
+          <a:lstStyle/>
+          <a:p>
+            <a:pPr algn="ctr"/>
+          </a:p>
+        </p:txBody>
+      </p:sp>
+      <p:pic>
+        <p:nvPicPr>
+          <p:cNvPr id="11" name="Picture 10" descr="user-check_00874E_30.png"/>
+          <p:cNvPicPr>
+            <a:picLocks noChangeAspect="1"/>
+          </p:cNvPicPr>
+          <p:nvPr/>
+        </p:nvPicPr>
+        <p:blipFill>
+          <a:blip r:embed="rId4"/>
+          <a:stretch>
+            <a:fillRect/>
+          </a:stretch>
+        </p:blipFill>
+        <p:spPr>
+          <a:xfrm>
+            <a:off x="6199632" y="3090672"/>
+            <a:ext cx="292608" cy="292608"/>
+          </a:xfrm>
+          <a:prstGeom prst="rect">
+            <a:avLst/>
+          </a:prstGeom>
+        </p:spPr>
+      </p:pic>
+      <p:sp>
+        <p:nvSpPr>
+          <p:cNvPr id="12" name="TextBox 11"/>
+          <p:cNvSpPr txBox="1"/>
+          <p:nvPr/>
+        </p:nvSpPr>
+        <p:spPr>
+          <a:xfrm>
+            <a:off x="6601968" y="3108960"/>
+            <a:ext cx="4370831" cy="457200"/>
+          </a:xfrm>
+          <a:prstGeom prst="rect">
+            <a:avLst/>
+          </a:prstGeom>
+          <a:noFill/>
+        </p:spPr>
+        <p:txBody>
+          <a:bodyPr wrap="square" lIns="45720" rIns="45720" tIns="18288" bIns="18288">
+            <a:spAutoFit/>
+          </a:bodyPr>
+          <a:lstStyle/>
+          <a:p>
+            <a:pPr algn="l">
+              <a:defRPr sz="1700" b="1">
+                <a:solidFill>
+                  <a:srgbClr val="00874E"/>
+                </a:solidFill>
+                <a:latin typeface="Calibri"/>
+              </a:defRPr>
+            </a:pPr>
+            <a:r>
+              <a:t>Avec persona (puissant)</a:t>
+            </a:r>
+          </a:p>
+        </p:txBody>
+      </p:sp>
+      <p:sp>
+        <p:nvSpPr>
+          <p:cNvPr id="13" name="TextBox 12"/>
+          <p:cNvSpPr txBox="1"/>
+          <p:nvPr/>
+        </p:nvSpPr>
+        <p:spPr>
+          <a:xfrm>
+            <a:off x="6217920" y="3703320"/>
+            <a:ext cx="4663440" cy="2331720"/>
+          </a:xfrm>
+          <a:prstGeom prst="rect">
+            <a:avLst/>
+          </a:prstGeom>
+          <a:noFill/>
+        </p:spPr>
+        <p:txBody>
+          <a:bodyPr wrap="square">
+            <a:spAutoFit/>
+          </a:bodyPr>
+          <a:lstStyle/>
+          <a:p>
+            <a:pPr>
+              <a:spcAft>
+                <a:spcPts val="400"/>
+              </a:spcAft>
+              <a:defRPr sz="1300">
+                <a:solidFill>
+                  <a:srgbClr val="2B2B2B"/>
+                </a:solidFill>
+                <a:latin typeface="Calibri"/>
+              </a:defRPr>
+            </a:pPr>
+            <a:r>
+              <a:t>«En tant que chef de projet senior, rédige un courriel de suivi technique»</a:t>
+            </a:r>
+          </a:p>
+          <a:p>
+            <a:pPr>
+              <a:spcAft>
+                <a:spcPts val="400"/>
+              </a:spcAft>
+              <a:defRPr sz="1300">
+                <a:solidFill>
+                  <a:srgbClr val="2B2B2B"/>
+                </a:solidFill>
+                <a:latin typeface="Calibri"/>
+              </a:defRPr>
+            </a:pPr>
+          </a:p>
+          <a:p>
+            <a:pPr>
+              <a:spcAft>
+                <a:spcPts val="400"/>
+              </a:spcAft>
+              <a:defRPr sz="1300">
+                <a:solidFill>
+                  <a:srgbClr val="2B2B2B"/>
+                </a:solidFill>
+                <a:latin typeface="Calibri"/>
+              </a:defRPr>
+            </a:pPr>
+            <a:r>
               <a:t>→ Réponse experte, ton adapté, détails pertinents</a:t>
+            </a:r>
+          </a:p>
+        </p:txBody>
+      </p:sp>
+      <p:sp>
+        <p:nvSpPr>
+          <p:cNvPr id="14" name="Rectangle 13"/>
+          <p:cNvSpPr/>
+          <p:nvPr/>
+        </p:nvSpPr>
+        <p:spPr>
+          <a:xfrm>
+            <a:off x="457200" y="6446520"/>
+            <a:ext cx="11274552" cy="13716"/>
+          </a:xfrm>
+          <a:prstGeom prst="rect">
+            <a:avLst/>
+          </a:prstGeom>
+          <a:solidFill>
+            <a:srgbClr val="00874E"/>
+          </a:solidFill>
+          <a:ln>
+            <a:noFill/>
+          </a:ln>
+          <a:effectLst/>
+        </p:spPr>
+        <p:style>
+          <a:lnRef idx="1">
+            <a:schemeClr val="accent1"/>
+          </a:lnRef>
+          <a:fillRef idx="3">
+            <a:schemeClr val="accent1"/>
+          </a:fillRef>
+          <a:effectRef idx="2">
+            <a:schemeClr val="accent1"/>
+          </a:effectRef>
+          <a:fontRef idx="minor">
+            <a:schemeClr val="lt1"/>
+          </a:fontRef>
+        </p:style>
+        <p:txBody>
+          <a:bodyPr rtlCol="0" anchor="ctr"/>
+          <a:lstStyle/>
+          <a:p>
+            <a:pPr algn="ctr"/>
+          </a:p>
+        </p:txBody>
+      </p:sp>
+      <p:sp>
+        <p:nvSpPr>
+          <p:cNvPr id="15" name="TextBox 14"/>
+          <p:cNvSpPr txBox="1"/>
+          <p:nvPr/>
+        </p:nvSpPr>
+        <p:spPr>
+          <a:xfrm>
+            <a:off x="457200" y="6537960"/>
+            <a:ext cx="5486400" cy="274320"/>
+          </a:xfrm>
+          <a:prstGeom prst="rect">
+            <a:avLst/>
+          </a:prstGeom>
+          <a:noFill/>
+        </p:spPr>
+        <p:txBody>
+          <a:bodyPr wrap="square" lIns="45720" rIns="45720" tIns="18288" bIns="18288">
+            <a:spAutoFit/>
+          </a:bodyPr>
+          <a:lstStyle/>
+          <a:p>
+            <a:pPr algn="l">
+              <a:defRPr sz="1000" b="0">
+                <a:solidFill>
+                  <a:srgbClr val="6B6B6B"/>
+                </a:solidFill>
+                <a:latin typeface="Calibri"/>
+              </a:defRPr>
+            </a:pPr>
+            <a:r>
+              <a:t>La minute Copilot</a:t>
+            </a:r>
+          </a:p>
+        </p:txBody>
+      </p:sp>
+      <p:sp>
+        <p:nvSpPr>
+          <p:cNvPr id="16" name="TextBox 15"/>
+          <p:cNvSpPr txBox="1"/>
+          <p:nvPr/>
+        </p:nvSpPr>
+        <p:spPr>
+          <a:xfrm>
+            <a:off x="10972800" y="6537960"/>
+            <a:ext cx="822960" cy="274320"/>
+          </a:xfrm>
+          <a:prstGeom prst="rect">
+            <a:avLst/>
+          </a:prstGeom>
+          <a:noFill/>
+        </p:spPr>
+        <p:txBody>
+          <a:bodyPr wrap="square" lIns="45720" rIns="45720" tIns="18288" bIns="18288">
+            <a:spAutoFit/>
+          </a:bodyPr>
+          <a:lstStyle/>
+          <a:p>
+            <a:pPr algn="r">
+              <a:defRPr sz="1000" b="0">
+                <a:solidFill>
+                  <a:srgbClr val="6B6B6B"/>
+                </a:solidFill>
+                <a:latin typeface="Calibri"/>
+              </a:defRPr>
+            </a:pPr>
+            <a:r>
+              <a:t>2</a:t>
             </a:r>
           </a:p>
         </p:txBody>
@@ -4476,7 +4774,7 @@
     <p:bg>
       <p:bgPr>
         <a:solidFill>
-          <a:srgbClr val="FFFFFF"/>
+          <a:srgbClr val="E6F0EA"/>
         </a:solidFill>
         <a:effectLst/>
       </p:bgPr>
@@ -4496,8 +4794,8 @@
         </p:nvSpPr>
         <p:spPr>
           <a:xfrm>
-            <a:off x="457200" y="274320"/>
-            <a:ext cx="10972800" cy="640080"/>
+            <a:off x="457200" y="365760"/>
+            <a:ext cx="10972800" cy="731520"/>
           </a:xfrm>
           <a:prstGeom prst="rect">
             <a:avLst/>
@@ -4505,21 +4803,21 @@
           <a:noFill/>
         </p:spPr>
         <p:txBody>
-          <a:bodyPr wrap="square">
+          <a:bodyPr wrap="square" lIns="45720" rIns="45720" tIns="18288" bIns="18288">
             <a:spAutoFit/>
           </a:bodyPr>
           <a:lstStyle/>
           <a:p>
             <a:pPr algn="l">
-              <a:defRPr sz="3200" b="1">
-                <a:solidFill>
-                  <a:srgbClr val="2B2B2B"/>
+              <a:defRPr sz="2800" b="1">
+                <a:solidFill>
+                  <a:srgbClr val="006B3F"/>
                 </a:solidFill>
                 <a:latin typeface="Calibri"/>
               </a:defRPr>
             </a:pPr>
             <a:r>
-              <a:t>📝 3 personas indispensables dans Outlook</a:t>
+              <a:t>3 personas indispensables dans Outlook</a:t>
             </a:r>
           </a:p>
         </p:txBody>
@@ -4532,8 +4830,8 @@
         </p:nvSpPr>
         <p:spPr>
           <a:xfrm>
-            <a:off x="457200" y="914400"/>
-            <a:ext cx="10972800" cy="457200"/>
+            <a:off x="457200" y="1005840"/>
+            <a:ext cx="10972800" cy="411480"/>
           </a:xfrm>
           <a:prstGeom prst="rect">
             <a:avLst/>
@@ -4541,13 +4839,13 @@
           <a:noFill/>
         </p:spPr>
         <p:txBody>
-          <a:bodyPr wrap="square">
+          <a:bodyPr wrap="square" lIns="45720" rIns="45720" tIns="18288" bIns="18288">
             <a:spAutoFit/>
           </a:bodyPr>
           <a:lstStyle/>
           <a:p>
             <a:pPr algn="l">
-              <a:defRPr sz="1800" b="0">
+              <a:defRPr sz="1500" b="0">
                 <a:solidFill>
                   <a:srgbClr val="6B6B6B"/>
                 </a:solidFill>
@@ -4562,97 +4860,25 @@
       </p:sp>
       <p:sp>
         <p:nvSpPr>
-          <p:cNvPr id="4" name="TextBox 3"/>
-          <p:cNvSpPr txBox="1"/>
-          <p:nvPr/>
-        </p:nvSpPr>
-        <p:spPr>
-          <a:xfrm>
-            <a:off x="457200" y="1554480"/>
-            <a:ext cx="10972800" cy="1371600"/>
-          </a:xfrm>
-          <a:prstGeom prst="rect">
-            <a:avLst/>
-          </a:prstGeom>
-          <a:noFill/>
-        </p:spPr>
-        <p:txBody>
-          <a:bodyPr wrap="square">
-            <a:spAutoFit/>
-          </a:bodyPr>
-          <a:lstStyle/>
-          <a:p>
-            <a:pPr>
-              <a:spcAft>
-                <a:spcPts val="400"/>
-              </a:spcAft>
-              <a:defRPr sz="1400">
-                <a:solidFill>
-                  <a:srgbClr val="2B2B2B"/>
-                </a:solidFill>
-                <a:latin typeface="Calibri"/>
-              </a:defRPr>
-            </a:pPr>
-            <a:r>
-              <a:t>• Ajoutez le persona au début du prompt</a:t>
-            </a:r>
-          </a:p>
-          <a:p>
-            <a:pPr>
-              <a:spcAft>
-                <a:spcPts val="400"/>
-              </a:spcAft>
-              <a:defRPr sz="1400">
-                <a:solidFill>
-                  <a:srgbClr val="2B2B2B"/>
-                </a:solidFill>
-                <a:latin typeface="Calibri"/>
-              </a:defRPr>
-            </a:pPr>
-            <a:r>
-              <a:t>• Copilot garde le contexte</a:t>
-            </a:r>
-          </a:p>
-          <a:p>
-            <a:pPr>
-              <a:spcAft>
-                <a:spcPts val="400"/>
-              </a:spcAft>
-              <a:defRPr sz="1400">
-                <a:solidFill>
-                  <a:srgbClr val="2B2B2B"/>
-                </a:solidFill>
-                <a:latin typeface="Calibri"/>
-              </a:defRPr>
-            </a:pPr>
-            <a:r>
-              <a:t>• Combinez persona + consigne + format</a:t>
-            </a:r>
-          </a:p>
-        </p:txBody>
-      </p:sp>
-      <p:sp>
-        <p:nvSpPr>
-          <p:cNvPr id="5" name="Rectangle 4"/>
+          <p:cNvPr id="4" name="Rectangle 3"/>
           <p:cNvSpPr/>
           <p:nvPr/>
         </p:nvSpPr>
         <p:spPr>
           <a:xfrm>
-            <a:off x="457200" y="3017520"/>
-            <a:ext cx="3383280" cy="3657600"/>
+            <a:off x="457200" y="1508760"/>
+            <a:ext cx="11274552" cy="18288"/>
           </a:xfrm>
           <a:prstGeom prst="rect">
             <a:avLst/>
           </a:prstGeom>
           <a:solidFill>
-            <a:srgbClr val="FFFFFF"/>
+            <a:srgbClr val="00874E"/>
           </a:solidFill>
           <a:ln>
-            <a:solidFill>
-              <a:srgbClr val="E0E0E0"/>
-            </a:solidFill>
+            <a:noFill/>
           </a:ln>
+          <a:effectLst/>
         </p:spPr>
         <p:style>
           <a:lnRef idx="1">
@@ -4678,50 +4904,14 @@
       </p:sp>
       <p:sp>
         <p:nvSpPr>
-          <p:cNvPr id="6" name="TextBox 5"/>
+          <p:cNvPr id="5" name="TextBox 4"/>
           <p:cNvSpPr txBox="1"/>
           <p:nvPr/>
         </p:nvSpPr>
         <p:spPr>
           <a:xfrm>
-            <a:off x="731520" y="3200400"/>
-            <a:ext cx="2834640" cy="457200"/>
-          </a:xfrm>
-          <a:prstGeom prst="rect">
-            <a:avLst/>
-          </a:prstGeom>
-          <a:noFill/>
-        </p:spPr>
-        <p:txBody>
-          <a:bodyPr wrap="square">
-            <a:spAutoFit/>
-          </a:bodyPr>
-          <a:lstStyle/>
-          <a:p>
-            <a:pPr algn="l">
-              <a:defRPr sz="1800" b="1">
-                <a:solidFill>
-                  <a:srgbClr val="0078D4"/>
-                </a:solidFill>
-                <a:latin typeface="Calibri"/>
-              </a:defRPr>
-            </a:pPr>
-            <a:r>
-              <a:t>👔 Persona professionnel</a:t>
-            </a:r>
-          </a:p>
-        </p:txBody>
-      </p:sp>
-      <p:sp>
-        <p:nvSpPr>
-          <p:cNvPr id="7" name="TextBox 6"/>
-          <p:cNvSpPr txBox="1"/>
-          <p:nvPr/>
-        </p:nvSpPr>
-        <p:spPr>
-          <a:xfrm>
-            <a:off x="731520" y="3657600"/>
-            <a:ext cx="2834640" cy="2743200"/>
+            <a:off x="457200" y="1737360"/>
+            <a:ext cx="10972800" cy="1188720"/>
           </a:xfrm>
           <a:prstGeom prst="rect">
             <a:avLst/>
@@ -4738,7 +4928,7 @@
               <a:spcAft>
                 <a:spcPts val="400"/>
               </a:spcAft>
-              <a:defRPr sz="1300">
+              <a:defRPr sz="1400">
                 <a:solidFill>
                   <a:srgbClr val="2B2B2B"/>
                 </a:solidFill>
@@ -4746,7 +4936,7 @@
               </a:defRPr>
             </a:pPr>
             <a:r>
-              <a:t>«En tant que directeur général, réponds à un partenaire d'affaires. Ton formel mais pas froid.»</a:t>
+              <a:t>• Ajoutez le persona au début du prompt</a:t>
             </a:r>
           </a:p>
           <a:p>
@@ -4754,20 +4944,23 @@
               <a:spcAft>
                 <a:spcPts val="400"/>
               </a:spcAft>
-              <a:defRPr sz="1300">
+              <a:defRPr sz="1400">
                 <a:solidFill>
                   <a:srgbClr val="2B2B2B"/>
                 </a:solidFill>
                 <a:latin typeface="Calibri"/>
               </a:defRPr>
             </a:pPr>
+            <a:r>
+              <a:t>• Copilot garde le contexte</a:t>
+            </a:r>
           </a:p>
           <a:p>
             <a:pPr>
               <a:spcAft>
                 <a:spcPts val="400"/>
               </a:spcAft>
-              <a:defRPr sz="1300">
+              <a:defRPr sz="1400">
                 <a:solidFill>
                   <a:srgbClr val="2B2B2B"/>
                 </a:solidFill>
@@ -4775,21 +4968,21 @@
               </a:defRPr>
             </a:pPr>
             <a:r>
-              <a:t>✅ Parfait pour clients et partenaires</a:t>
-            </a:r>
-          </a:p>
-        </p:txBody>
-      </p:sp>
-      <p:sp>
-        <p:nvSpPr>
-          <p:cNvPr id="8" name="Rectangle 7"/>
+              <a:t>• Combinez persona + consigne + format</a:t>
+            </a:r>
+          </a:p>
+        </p:txBody>
+      </p:sp>
+      <p:sp>
+        <p:nvSpPr>
+          <p:cNvPr id="6" name="Rectangle 5"/>
           <p:cNvSpPr/>
           <p:nvPr/>
         </p:nvSpPr>
         <p:spPr>
           <a:xfrm>
-            <a:off x="4114800" y="3017520"/>
-            <a:ext cx="3383280" cy="3657600"/>
+            <a:off x="457200" y="2926080"/>
+            <a:ext cx="3383280" cy="3291840"/>
           </a:xfrm>
           <a:prstGeom prst="rect">
             <a:avLst/>
@@ -4802,6 +4995,7 @@
               <a:srgbClr val="E0E0E0"/>
             </a:solidFill>
           </a:ln>
+          <a:effectLst/>
         </p:spPr>
         <p:style>
           <a:lnRef idx="1">
@@ -4825,6 +5019,66 @@
           </a:p>
         </p:txBody>
       </p:sp>
+      <p:pic>
+        <p:nvPicPr>
+          <p:cNvPr id="7" name="Picture 6" descr="briefcase_00874E_30.png"/>
+          <p:cNvPicPr>
+            <a:picLocks noChangeAspect="1"/>
+          </p:cNvPicPr>
+          <p:nvPr/>
+        </p:nvPicPr>
+        <p:blipFill>
+          <a:blip r:embed="rId3"/>
+          <a:stretch>
+            <a:fillRect/>
+          </a:stretch>
+        </p:blipFill>
+        <p:spPr>
+          <a:xfrm>
+            <a:off x="713232" y="3090672"/>
+            <a:ext cx="292608" cy="292608"/>
+          </a:xfrm>
+          <a:prstGeom prst="rect">
+            <a:avLst/>
+          </a:prstGeom>
+        </p:spPr>
+      </p:pic>
+      <p:sp>
+        <p:nvSpPr>
+          <p:cNvPr id="8" name="TextBox 7"/>
+          <p:cNvSpPr txBox="1"/>
+          <p:nvPr/>
+        </p:nvSpPr>
+        <p:spPr>
+          <a:xfrm>
+            <a:off x="1115568" y="3108960"/>
+            <a:ext cx="2542032" cy="457200"/>
+          </a:xfrm>
+          <a:prstGeom prst="rect">
+            <a:avLst/>
+          </a:prstGeom>
+          <a:noFill/>
+        </p:spPr>
+        <p:txBody>
+          <a:bodyPr wrap="square" lIns="45720" rIns="45720" tIns="18288" bIns="18288">
+            <a:spAutoFit/>
+          </a:bodyPr>
+          <a:lstStyle/>
+          <a:p>
+            <a:pPr algn="l">
+              <a:defRPr sz="1700" b="1">
+                <a:solidFill>
+                  <a:srgbClr val="00874E"/>
+                </a:solidFill>
+                <a:latin typeface="Calibri"/>
+              </a:defRPr>
+            </a:pPr>
+            <a:r>
+              <a:t>Persona professionnel</a:t>
+            </a:r>
+          </a:p>
+        </p:txBody>
+      </p:sp>
       <p:sp>
         <p:nvSpPr>
           <p:cNvPr id="9" name="TextBox 8"/>
@@ -4833,44 +5087,8 @@
         </p:nvSpPr>
         <p:spPr>
           <a:xfrm>
-            <a:off x="4389120" y="3200400"/>
-            <a:ext cx="2834640" cy="457200"/>
-          </a:xfrm>
-          <a:prstGeom prst="rect">
-            <a:avLst/>
-          </a:prstGeom>
-          <a:noFill/>
-        </p:spPr>
-        <p:txBody>
-          <a:bodyPr wrap="square">
-            <a:spAutoFit/>
-          </a:bodyPr>
-          <a:lstStyle/>
-          <a:p>
-            <a:pPr algn="l">
-              <a:defRPr sz="1800" b="1">
-                <a:solidFill>
-                  <a:srgbClr val="10B981"/>
-                </a:solidFill>
-                <a:latin typeface="Calibri"/>
-              </a:defRPr>
-            </a:pPr>
-            <a:r>
-              <a:t>🤝 Persona collaborateur</a:t>
-            </a:r>
-          </a:p>
-        </p:txBody>
-      </p:sp>
-      <p:sp>
-        <p:nvSpPr>
-          <p:cNvPr id="10" name="TextBox 9"/>
-          <p:cNvSpPr txBox="1"/>
-          <p:nvPr/>
-        </p:nvSpPr>
-        <p:spPr>
-          <a:xfrm>
-            <a:off x="4389120" y="3657600"/>
-            <a:ext cx="2834640" cy="2743200"/>
+            <a:off x="731520" y="3703320"/>
+            <a:ext cx="2834640" cy="2331720"/>
           </a:xfrm>
           <a:prstGeom prst="rect">
             <a:avLst/>
@@ -4895,7 +5113,7 @@
               </a:defRPr>
             </a:pPr>
             <a:r>
-              <a:t>«En tant que collègue, écris à mon équipe. On se tutoie. Sois direct et amical.»</a:t>
+              <a:t>«En tant que directeur général, réponds à un partenaire d'affaires. Ton formel mais pas froid.»</a:t>
             </a:r>
           </a:p>
           <a:p>
@@ -4924,21 +5142,21 @@
               </a:defRPr>
             </a:pPr>
             <a:r>
-              <a:t>✅ Parfait pour interne</a:t>
-            </a:r>
-          </a:p>
-        </p:txBody>
-      </p:sp>
-      <p:sp>
-        <p:nvSpPr>
-          <p:cNvPr id="11" name="Rectangle 10"/>
+              <a:t>Parfait pour clients et partenaires</a:t>
+            </a:r>
+          </a:p>
+        </p:txBody>
+      </p:sp>
+      <p:sp>
+        <p:nvSpPr>
+          <p:cNvPr id="10" name="Rectangle 9"/>
           <p:cNvSpPr/>
           <p:nvPr/>
         </p:nvSpPr>
         <p:spPr>
           <a:xfrm>
-            <a:off x="7772400" y="3017520"/>
-            <a:ext cx="3383280" cy="3657600"/>
+            <a:off x="4114800" y="2926080"/>
+            <a:ext cx="3383280" cy="3291840"/>
           </a:xfrm>
           <a:prstGeom prst="rect">
             <a:avLst/>
@@ -4951,6 +5169,7 @@
               <a:srgbClr val="E0E0E0"/>
             </a:solidFill>
           </a:ln>
+          <a:effectLst/>
         </p:spPr>
         <p:style>
           <a:lnRef idx="1">
@@ -4974,6 +5193,30 @@
           </a:p>
         </p:txBody>
       </p:sp>
+      <p:pic>
+        <p:nvPicPr>
+          <p:cNvPr id="11" name="Picture 10" descr="users_00874E_30.png"/>
+          <p:cNvPicPr>
+            <a:picLocks noChangeAspect="1"/>
+          </p:cNvPicPr>
+          <p:nvPr/>
+        </p:nvPicPr>
+        <p:blipFill>
+          <a:blip r:embed="rId4"/>
+          <a:stretch>
+            <a:fillRect/>
+          </a:stretch>
+        </p:blipFill>
+        <p:spPr>
+          <a:xfrm>
+            <a:off x="4370832" y="3090672"/>
+            <a:ext cx="292608" cy="292608"/>
+          </a:xfrm>
+          <a:prstGeom prst="rect">
+            <a:avLst/>
+          </a:prstGeom>
+        </p:spPr>
+      </p:pic>
       <p:sp>
         <p:nvSpPr>
           <p:cNvPr id="12" name="TextBox 11"/>
@@ -4982,8 +5225,8 @@
         </p:nvSpPr>
         <p:spPr>
           <a:xfrm>
-            <a:off x="8046720" y="3200400"/>
-            <a:ext cx="2834640" cy="457200"/>
+            <a:off x="4773168" y="3108960"/>
+            <a:ext cx="2542031" cy="457200"/>
           </a:xfrm>
           <a:prstGeom prst="rect">
             <a:avLst/>
@@ -4991,21 +5234,21 @@
           <a:noFill/>
         </p:spPr>
         <p:txBody>
-          <a:bodyPr wrap="square">
+          <a:bodyPr wrap="square" lIns="45720" rIns="45720" tIns="18288" bIns="18288">
             <a:spAutoFit/>
           </a:bodyPr>
           <a:lstStyle/>
           <a:p>
             <a:pPr algn="l">
-              <a:defRPr sz="1800" b="1">
-                <a:solidFill>
-                  <a:srgbClr val="F59E0B"/>
+              <a:defRPr sz="1700" b="1">
+                <a:solidFill>
+                  <a:srgbClr val="00874E"/>
                 </a:solidFill>
                 <a:latin typeface="Calibri"/>
               </a:defRPr>
             </a:pPr>
             <a:r>
-              <a:t>🎓 Persona vulgarisateur</a:t>
+              <a:t>Persona collaborateur</a:t>
             </a:r>
           </a:p>
         </p:txBody>
@@ -5018,8 +5261,8 @@
         </p:nvSpPr>
         <p:spPr>
           <a:xfrm>
-            <a:off x="8046720" y="3657600"/>
-            <a:ext cx="2834640" cy="2743200"/>
+            <a:off x="4389120" y="3703320"/>
+            <a:ext cx="2834640" cy="2331720"/>
           </a:xfrm>
           <a:prstGeom prst="rect">
             <a:avLst/>
@@ -5044,7 +5287,7 @@
               </a:defRPr>
             </a:pPr>
             <a:r>
-              <a:t>«En tant que formateur, explique ce concept technique simplement. Pas de jargon.»</a:t>
+              <a:t>«En tant que collègue, écris à mon équipe. On se tutoie. Sois direct et amical.»</a:t>
             </a:r>
           </a:p>
           <a:p>
@@ -5073,7 +5316,297 @@
               </a:defRPr>
             </a:pPr>
             <a:r>
-              <a:t>✅ Parfait pour IT vers non-IT</a:t>
+              <a:t>Parfait pour interne</a:t>
+            </a:r>
+          </a:p>
+        </p:txBody>
+      </p:sp>
+      <p:sp>
+        <p:nvSpPr>
+          <p:cNvPr id="14" name="Rectangle 13"/>
+          <p:cNvSpPr/>
+          <p:nvPr/>
+        </p:nvSpPr>
+        <p:spPr>
+          <a:xfrm>
+            <a:off x="7772400" y="2926080"/>
+            <a:ext cx="3383280" cy="3291840"/>
+          </a:xfrm>
+          <a:prstGeom prst="rect">
+            <a:avLst/>
+          </a:prstGeom>
+          <a:solidFill>
+            <a:srgbClr val="FFFFFF"/>
+          </a:solidFill>
+          <a:ln>
+            <a:solidFill>
+              <a:srgbClr val="E0E0E0"/>
+            </a:solidFill>
+          </a:ln>
+          <a:effectLst/>
+        </p:spPr>
+        <p:style>
+          <a:lnRef idx="1">
+            <a:schemeClr val="accent1"/>
+          </a:lnRef>
+          <a:fillRef idx="3">
+            <a:schemeClr val="accent1"/>
+          </a:fillRef>
+          <a:effectRef idx="2">
+            <a:schemeClr val="accent1"/>
+          </a:effectRef>
+          <a:fontRef idx="minor">
+            <a:schemeClr val="lt1"/>
+          </a:fontRef>
+        </p:style>
+        <p:txBody>
+          <a:bodyPr rtlCol="0" anchor="ctr"/>
+          <a:lstStyle/>
+          <a:p>
+            <a:pPr algn="ctr"/>
+          </a:p>
+        </p:txBody>
+      </p:sp>
+      <p:pic>
+        <p:nvPicPr>
+          <p:cNvPr id="15" name="Picture 14" descr="graduation-cap_F59E0B_30.png"/>
+          <p:cNvPicPr>
+            <a:picLocks noChangeAspect="1"/>
+          </p:cNvPicPr>
+          <p:nvPr/>
+        </p:nvPicPr>
+        <p:blipFill>
+          <a:blip r:embed="rId5"/>
+          <a:stretch>
+            <a:fillRect/>
+          </a:stretch>
+        </p:blipFill>
+        <p:spPr>
+          <a:xfrm>
+            <a:off x="8028431" y="3090672"/>
+            <a:ext cx="292608" cy="292608"/>
+          </a:xfrm>
+          <a:prstGeom prst="rect">
+            <a:avLst/>
+          </a:prstGeom>
+        </p:spPr>
+      </p:pic>
+      <p:sp>
+        <p:nvSpPr>
+          <p:cNvPr id="16" name="TextBox 15"/>
+          <p:cNvSpPr txBox="1"/>
+          <p:nvPr/>
+        </p:nvSpPr>
+        <p:spPr>
+          <a:xfrm>
+            <a:off x="8430767" y="3108960"/>
+            <a:ext cx="2542032" cy="457200"/>
+          </a:xfrm>
+          <a:prstGeom prst="rect">
+            <a:avLst/>
+          </a:prstGeom>
+          <a:noFill/>
+        </p:spPr>
+        <p:txBody>
+          <a:bodyPr wrap="square" lIns="45720" rIns="45720" tIns="18288" bIns="18288">
+            <a:spAutoFit/>
+          </a:bodyPr>
+          <a:lstStyle/>
+          <a:p>
+            <a:pPr algn="l">
+              <a:defRPr sz="1700" b="1">
+                <a:solidFill>
+                  <a:srgbClr val="F59E0B"/>
+                </a:solidFill>
+                <a:latin typeface="Calibri"/>
+              </a:defRPr>
+            </a:pPr>
+            <a:r>
+              <a:t>Persona vulgarisateur</a:t>
+            </a:r>
+          </a:p>
+        </p:txBody>
+      </p:sp>
+      <p:sp>
+        <p:nvSpPr>
+          <p:cNvPr id="17" name="TextBox 16"/>
+          <p:cNvSpPr txBox="1"/>
+          <p:nvPr/>
+        </p:nvSpPr>
+        <p:spPr>
+          <a:xfrm>
+            <a:off x="8046720" y="3703320"/>
+            <a:ext cx="2834640" cy="2331720"/>
+          </a:xfrm>
+          <a:prstGeom prst="rect">
+            <a:avLst/>
+          </a:prstGeom>
+          <a:noFill/>
+        </p:spPr>
+        <p:txBody>
+          <a:bodyPr wrap="square">
+            <a:spAutoFit/>
+          </a:bodyPr>
+          <a:lstStyle/>
+          <a:p>
+            <a:pPr>
+              <a:spcAft>
+                <a:spcPts val="400"/>
+              </a:spcAft>
+              <a:defRPr sz="1300">
+                <a:solidFill>
+                  <a:srgbClr val="2B2B2B"/>
+                </a:solidFill>
+                <a:latin typeface="Calibri"/>
+              </a:defRPr>
+            </a:pPr>
+            <a:r>
+              <a:t>«En tant que formateur, explique ce concept technique simplement. Pas de jargon.»</a:t>
+            </a:r>
+          </a:p>
+          <a:p>
+            <a:pPr>
+              <a:spcAft>
+                <a:spcPts val="400"/>
+              </a:spcAft>
+              <a:defRPr sz="1300">
+                <a:solidFill>
+                  <a:srgbClr val="2B2B2B"/>
+                </a:solidFill>
+                <a:latin typeface="Calibri"/>
+              </a:defRPr>
+            </a:pPr>
+          </a:p>
+          <a:p>
+            <a:pPr>
+              <a:spcAft>
+                <a:spcPts val="400"/>
+              </a:spcAft>
+              <a:defRPr sz="1300">
+                <a:solidFill>
+                  <a:srgbClr val="2B2B2B"/>
+                </a:solidFill>
+                <a:latin typeface="Calibri"/>
+              </a:defRPr>
+            </a:pPr>
+            <a:r>
+              <a:t>Parfait pour IT vers non-IT</a:t>
+            </a:r>
+          </a:p>
+        </p:txBody>
+      </p:sp>
+      <p:sp>
+        <p:nvSpPr>
+          <p:cNvPr id="18" name="Rectangle 17"/>
+          <p:cNvSpPr/>
+          <p:nvPr/>
+        </p:nvSpPr>
+        <p:spPr>
+          <a:xfrm>
+            <a:off x="457200" y="6446520"/>
+            <a:ext cx="11274552" cy="13716"/>
+          </a:xfrm>
+          <a:prstGeom prst="rect">
+            <a:avLst/>
+          </a:prstGeom>
+          <a:solidFill>
+            <a:srgbClr val="00874E"/>
+          </a:solidFill>
+          <a:ln>
+            <a:noFill/>
+          </a:ln>
+          <a:effectLst/>
+        </p:spPr>
+        <p:style>
+          <a:lnRef idx="1">
+            <a:schemeClr val="accent1"/>
+          </a:lnRef>
+          <a:fillRef idx="3">
+            <a:schemeClr val="accent1"/>
+          </a:fillRef>
+          <a:effectRef idx="2">
+            <a:schemeClr val="accent1"/>
+          </a:effectRef>
+          <a:fontRef idx="minor">
+            <a:schemeClr val="lt1"/>
+          </a:fontRef>
+        </p:style>
+        <p:txBody>
+          <a:bodyPr rtlCol="0" anchor="ctr"/>
+          <a:lstStyle/>
+          <a:p>
+            <a:pPr algn="ctr"/>
+          </a:p>
+        </p:txBody>
+      </p:sp>
+      <p:sp>
+        <p:nvSpPr>
+          <p:cNvPr id="19" name="TextBox 18"/>
+          <p:cNvSpPr txBox="1"/>
+          <p:nvPr/>
+        </p:nvSpPr>
+        <p:spPr>
+          <a:xfrm>
+            <a:off x="457200" y="6537960"/>
+            <a:ext cx="5486400" cy="274320"/>
+          </a:xfrm>
+          <a:prstGeom prst="rect">
+            <a:avLst/>
+          </a:prstGeom>
+          <a:noFill/>
+        </p:spPr>
+        <p:txBody>
+          <a:bodyPr wrap="square" lIns="45720" rIns="45720" tIns="18288" bIns="18288">
+            <a:spAutoFit/>
+          </a:bodyPr>
+          <a:lstStyle/>
+          <a:p>
+            <a:pPr algn="l">
+              <a:defRPr sz="1000" b="0">
+                <a:solidFill>
+                  <a:srgbClr val="6B6B6B"/>
+                </a:solidFill>
+                <a:latin typeface="Calibri"/>
+              </a:defRPr>
+            </a:pPr>
+            <a:r>
+              <a:t>La minute Copilot</a:t>
+            </a:r>
+          </a:p>
+        </p:txBody>
+      </p:sp>
+      <p:sp>
+        <p:nvSpPr>
+          <p:cNvPr id="20" name="TextBox 19"/>
+          <p:cNvSpPr txBox="1"/>
+          <p:nvPr/>
+        </p:nvSpPr>
+        <p:spPr>
+          <a:xfrm>
+            <a:off x="10972800" y="6537960"/>
+            <a:ext cx="822960" cy="274320"/>
+          </a:xfrm>
+          <a:prstGeom prst="rect">
+            <a:avLst/>
+          </a:prstGeom>
+          <a:noFill/>
+        </p:spPr>
+        <p:txBody>
+          <a:bodyPr wrap="square" lIns="45720" rIns="45720" tIns="18288" bIns="18288">
+            <a:spAutoFit/>
+          </a:bodyPr>
+          <a:lstStyle/>
+          <a:p>
+            <a:pPr algn="r">
+              <a:defRPr sz="1000" b="0">
+                <a:solidFill>
+                  <a:srgbClr val="6B6B6B"/>
+                </a:solidFill>
+                <a:latin typeface="Calibri"/>
+              </a:defRPr>
+            </a:pPr>
+            <a:r>
+              <a:t>3</a:t>
             </a:r>
           </a:p>
         </p:txBody>
@@ -5092,7 +5625,7 @@
     <p:bg>
       <p:bgPr>
         <a:solidFill>
-          <a:srgbClr val="F0F4F8"/>
+          <a:srgbClr val="E6F0EA"/>
         </a:solidFill>
         <a:effectLst/>
       </p:bgPr>
@@ -5112,8 +5645,8 @@
         </p:nvSpPr>
         <p:spPr>
           <a:xfrm>
-            <a:off x="457200" y="274320"/>
-            <a:ext cx="10972800" cy="640080"/>
+            <a:off x="457200" y="365760"/>
+            <a:ext cx="10972800" cy="731520"/>
           </a:xfrm>
           <a:prstGeom prst="rect">
             <a:avLst/>
@@ -5121,21 +5654,21 @@
           <a:noFill/>
         </p:spPr>
         <p:txBody>
-          <a:bodyPr wrap="square">
+          <a:bodyPr wrap="square" lIns="45720" rIns="45720" tIns="18288" bIns="18288">
             <a:spAutoFit/>
           </a:bodyPr>
           <a:lstStyle/>
           <a:p>
             <a:pPr algn="l">
-              <a:defRPr sz="3200" b="1">
-                <a:solidFill>
-                  <a:srgbClr val="2B2B2B"/>
+              <a:defRPr sz="2800" b="1">
+                <a:solidFill>
+                  <a:srgbClr val="006B3F"/>
                 </a:solidFill>
                 <a:latin typeface="Calibri"/>
               </a:defRPr>
             </a:pPr>
             <a:r>
-              <a:t>💡 Exemples concrets — Avant / Après</a:t>
+              <a:t>Exemples concrets — Avant / Après</a:t>
             </a:r>
           </a:p>
         </p:txBody>
@@ -5148,20 +5681,19 @@
         </p:nvSpPr>
         <p:spPr>
           <a:xfrm>
-            <a:off x="457200" y="1188720"/>
-            <a:ext cx="5212080" cy="5029200"/>
+            <a:off x="457200" y="1234440"/>
+            <a:ext cx="11274552" cy="18288"/>
           </a:xfrm>
           <a:prstGeom prst="rect">
             <a:avLst/>
           </a:prstGeom>
           <a:solidFill>
-            <a:srgbClr val="FFFFFF"/>
+            <a:srgbClr val="00874E"/>
           </a:solidFill>
           <a:ln>
-            <a:solidFill>
-              <a:srgbClr val="E0E0E0"/>
-            </a:solidFill>
+            <a:noFill/>
           </a:ln>
+          <a:effectLst/>
         </p:spPr>
         <p:style>
           <a:lnRef idx="1">
@@ -5187,118 +5719,14 @@
       </p:sp>
       <p:sp>
         <p:nvSpPr>
-          <p:cNvPr id="4" name="TextBox 3"/>
-          <p:cNvSpPr txBox="1"/>
-          <p:nvPr/>
-        </p:nvSpPr>
-        <p:spPr>
-          <a:xfrm>
-            <a:off x="731520" y="1371600"/>
-            <a:ext cx="4663440" cy="457200"/>
-          </a:xfrm>
-          <a:prstGeom prst="rect">
-            <a:avLst/>
-          </a:prstGeom>
-          <a:noFill/>
-        </p:spPr>
-        <p:txBody>
-          <a:bodyPr wrap="square">
-            <a:spAutoFit/>
-          </a:bodyPr>
-          <a:lstStyle/>
-          <a:p>
-            <a:pPr algn="l">
-              <a:defRPr sz="1800" b="1">
-                <a:solidFill>
-                  <a:srgbClr val="EF4444"/>
-                </a:solidFill>
-                <a:latin typeface="Calibri"/>
-              </a:defRPr>
-            </a:pPr>
-            <a:r>
-              <a:t>❌ AVANT — Sans persona</a:t>
-            </a:r>
-          </a:p>
-        </p:txBody>
-      </p:sp>
-      <p:sp>
-        <p:nvSpPr>
-          <p:cNvPr id="5" name="TextBox 4"/>
-          <p:cNvSpPr txBox="1"/>
-          <p:nvPr/>
-        </p:nvSpPr>
-        <p:spPr>
-          <a:xfrm>
-            <a:off x="731520" y="1828800"/>
-            <a:ext cx="4663440" cy="4114800"/>
-          </a:xfrm>
-          <a:prstGeom prst="rect">
-            <a:avLst/>
-          </a:prstGeom>
-          <a:noFill/>
-        </p:spPr>
-        <p:txBody>
-          <a:bodyPr wrap="square">
-            <a:spAutoFit/>
-          </a:bodyPr>
-          <a:lstStyle/>
-          <a:p>
-            <a:pPr>
-              <a:spcAft>
-                <a:spcPts val="400"/>
-              </a:spcAft>
-              <a:defRPr sz="1300">
-                <a:solidFill>
-                  <a:srgbClr val="2B2B2B"/>
-                </a:solidFill>
-                <a:latin typeface="Calibri"/>
-              </a:defRPr>
-            </a:pPr>
-            <a:r>
-              <a:t>«Draft a reply to this email»</a:t>
-            </a:r>
-          </a:p>
-          <a:p>
-            <a:pPr>
-              <a:spcAft>
-                <a:spcPts val="400"/>
-              </a:spcAft>
-              <a:defRPr sz="1300">
-                <a:solidFill>
-                  <a:srgbClr val="2B2B2B"/>
-                </a:solidFill>
-                <a:latin typeface="Calibri"/>
-              </a:defRPr>
-            </a:pPr>
-          </a:p>
-          <a:p>
-            <a:pPr>
-              <a:spcAft>
-                <a:spcPts val="400"/>
-              </a:spcAft>
-              <a:defRPr sz="1300">
-                <a:solidFill>
-                  <a:srgbClr val="2B2B2B"/>
-                </a:solidFill>
-                <a:latin typeface="Calibri"/>
-              </a:defRPr>
-            </a:pPr>
-            <a:r>
-              <a:t>→ Réponse générique, sans contexte. Temps perdu à réécrire.</a:t>
-            </a:r>
-          </a:p>
-        </p:txBody>
-      </p:sp>
-      <p:sp>
-        <p:nvSpPr>
-          <p:cNvPr id="6" name="Rectangle 5"/>
+          <p:cNvPr id="4" name="Rectangle 3"/>
           <p:cNvSpPr/>
           <p:nvPr/>
         </p:nvSpPr>
         <p:spPr>
           <a:xfrm>
-            <a:off x="5943600" y="1188720"/>
-            <a:ext cx="5212080" cy="5029200"/>
+            <a:off x="457200" y="1463040"/>
+            <a:ext cx="5212080" cy="4754880"/>
           </a:xfrm>
           <a:prstGeom prst="rect">
             <a:avLst/>
@@ -5311,6 +5739,7 @@
               <a:srgbClr val="E0E0E0"/>
             </a:solidFill>
           </a:ln>
+          <a:effectLst/>
         </p:spPr>
         <p:style>
           <a:lnRef idx="1">
@@ -5334,6 +5763,66 @@
           </a:p>
         </p:txBody>
       </p:sp>
+      <p:pic>
+        <p:nvPicPr>
+          <p:cNvPr id="5" name="Picture 4" descr="circle-x_EF4444_30.png"/>
+          <p:cNvPicPr>
+            <a:picLocks noChangeAspect="1"/>
+          </p:cNvPicPr>
+          <p:nvPr/>
+        </p:nvPicPr>
+        <p:blipFill>
+          <a:blip r:embed="rId3"/>
+          <a:stretch>
+            <a:fillRect/>
+          </a:stretch>
+        </p:blipFill>
+        <p:spPr>
+          <a:xfrm>
+            <a:off x="713232" y="1627632"/>
+            <a:ext cx="292608" cy="292608"/>
+          </a:xfrm>
+          <a:prstGeom prst="rect">
+            <a:avLst/>
+          </a:prstGeom>
+        </p:spPr>
+      </p:pic>
+      <p:sp>
+        <p:nvSpPr>
+          <p:cNvPr id="6" name="TextBox 5"/>
+          <p:cNvSpPr txBox="1"/>
+          <p:nvPr/>
+        </p:nvSpPr>
+        <p:spPr>
+          <a:xfrm>
+            <a:off x="1115568" y="1645920"/>
+            <a:ext cx="4370832" cy="457200"/>
+          </a:xfrm>
+          <a:prstGeom prst="rect">
+            <a:avLst/>
+          </a:prstGeom>
+          <a:noFill/>
+        </p:spPr>
+        <p:txBody>
+          <a:bodyPr wrap="square" lIns="45720" rIns="45720" tIns="18288" bIns="18288">
+            <a:spAutoFit/>
+          </a:bodyPr>
+          <a:lstStyle/>
+          <a:p>
+            <a:pPr algn="l">
+              <a:defRPr sz="1700" b="1">
+                <a:solidFill>
+                  <a:srgbClr val="EF4444"/>
+                </a:solidFill>
+                <a:latin typeface="Calibri"/>
+              </a:defRPr>
+            </a:pPr>
+            <a:r>
+              <a:t>AVANT — Sans persona</a:t>
+            </a:r>
+          </a:p>
+        </p:txBody>
+      </p:sp>
       <p:sp>
         <p:nvSpPr>
           <p:cNvPr id="7" name="TextBox 6"/>
@@ -5342,44 +5831,8 @@
         </p:nvSpPr>
         <p:spPr>
           <a:xfrm>
-            <a:off x="6217920" y="1371600"/>
-            <a:ext cx="4663440" cy="457200"/>
-          </a:xfrm>
-          <a:prstGeom prst="rect">
-            <a:avLst/>
-          </a:prstGeom>
-          <a:noFill/>
-        </p:spPr>
-        <p:txBody>
-          <a:bodyPr wrap="square">
-            <a:spAutoFit/>
-          </a:bodyPr>
-          <a:lstStyle/>
-          <a:p>
-            <a:pPr algn="l">
-              <a:defRPr sz="1800" b="1">
-                <a:solidFill>
-                  <a:srgbClr val="10B981"/>
-                </a:solidFill>
-                <a:latin typeface="Calibri"/>
-              </a:defRPr>
-            </a:pPr>
-            <a:r>
-              <a:t>✅ APRÈS — Avec persona</a:t>
-            </a:r>
-          </a:p>
-        </p:txBody>
-      </p:sp>
-      <p:sp>
-        <p:nvSpPr>
-          <p:cNvPr id="8" name="TextBox 7"/>
-          <p:cNvSpPr txBox="1"/>
-          <p:nvPr/>
-        </p:nvSpPr>
-        <p:spPr>
-          <a:xfrm>
-            <a:off x="6217920" y="1828800"/>
-            <a:ext cx="4663440" cy="4114800"/>
+            <a:off x="731520" y="2240280"/>
+            <a:ext cx="4663440" cy="3794760"/>
           </a:xfrm>
           <a:prstGeom prst="rect">
             <a:avLst/>
@@ -5404,7 +5857,7 @@
               </a:defRPr>
             </a:pPr>
             <a:r>
-              <a:t>«As a senior project manager, draft a reply to this stakeholder. Propose a timeline.»</a:t>
+              <a:t>«Draft a reply to this email»</a:t>
             </a:r>
           </a:p>
           <a:p>
@@ -5433,7 +5886,297 @@
               </a:defRPr>
             </a:pPr>
             <a:r>
+              <a:t>→ Réponse générique, sans contexte. Temps perdu à réécrire.</a:t>
+            </a:r>
+          </a:p>
+        </p:txBody>
+      </p:sp>
+      <p:sp>
+        <p:nvSpPr>
+          <p:cNvPr id="8" name="Rectangle 7"/>
+          <p:cNvSpPr/>
+          <p:nvPr/>
+        </p:nvSpPr>
+        <p:spPr>
+          <a:xfrm>
+            <a:off x="5943600" y="1463040"/>
+            <a:ext cx="5212080" cy="4754880"/>
+          </a:xfrm>
+          <a:prstGeom prst="rect">
+            <a:avLst/>
+          </a:prstGeom>
+          <a:solidFill>
+            <a:srgbClr val="FFFFFF"/>
+          </a:solidFill>
+          <a:ln>
+            <a:solidFill>
+              <a:srgbClr val="E0E0E0"/>
+            </a:solidFill>
+          </a:ln>
+          <a:effectLst/>
+        </p:spPr>
+        <p:style>
+          <a:lnRef idx="1">
+            <a:schemeClr val="accent1"/>
+          </a:lnRef>
+          <a:fillRef idx="3">
+            <a:schemeClr val="accent1"/>
+          </a:fillRef>
+          <a:effectRef idx="2">
+            <a:schemeClr val="accent1"/>
+          </a:effectRef>
+          <a:fontRef idx="minor">
+            <a:schemeClr val="lt1"/>
+          </a:fontRef>
+        </p:style>
+        <p:txBody>
+          <a:bodyPr rtlCol="0" anchor="ctr"/>
+          <a:lstStyle/>
+          <a:p>
+            <a:pPr algn="ctr"/>
+          </a:p>
+        </p:txBody>
+      </p:sp>
+      <p:pic>
+        <p:nvPicPr>
+          <p:cNvPr id="9" name="Picture 8" descr="circle-check_00874E_30.png"/>
+          <p:cNvPicPr>
+            <a:picLocks noChangeAspect="1"/>
+          </p:cNvPicPr>
+          <p:nvPr/>
+        </p:nvPicPr>
+        <p:blipFill>
+          <a:blip r:embed="rId4"/>
+          <a:stretch>
+            <a:fillRect/>
+          </a:stretch>
+        </p:blipFill>
+        <p:spPr>
+          <a:xfrm>
+            <a:off x="6199632" y="1627632"/>
+            <a:ext cx="292608" cy="292608"/>
+          </a:xfrm>
+          <a:prstGeom prst="rect">
+            <a:avLst/>
+          </a:prstGeom>
+        </p:spPr>
+      </p:pic>
+      <p:sp>
+        <p:nvSpPr>
+          <p:cNvPr id="10" name="TextBox 9"/>
+          <p:cNvSpPr txBox="1"/>
+          <p:nvPr/>
+        </p:nvSpPr>
+        <p:spPr>
+          <a:xfrm>
+            <a:off x="6601968" y="1645920"/>
+            <a:ext cx="4370831" cy="457200"/>
+          </a:xfrm>
+          <a:prstGeom prst="rect">
+            <a:avLst/>
+          </a:prstGeom>
+          <a:noFill/>
+        </p:spPr>
+        <p:txBody>
+          <a:bodyPr wrap="square" lIns="45720" rIns="45720" tIns="18288" bIns="18288">
+            <a:spAutoFit/>
+          </a:bodyPr>
+          <a:lstStyle/>
+          <a:p>
+            <a:pPr algn="l">
+              <a:defRPr sz="1700" b="1">
+                <a:solidFill>
+                  <a:srgbClr val="00874E"/>
+                </a:solidFill>
+                <a:latin typeface="Calibri"/>
+              </a:defRPr>
+            </a:pPr>
+            <a:r>
+              <a:t>APRÈS — Avec persona</a:t>
+            </a:r>
+          </a:p>
+        </p:txBody>
+      </p:sp>
+      <p:sp>
+        <p:nvSpPr>
+          <p:cNvPr id="11" name="TextBox 10"/>
+          <p:cNvSpPr txBox="1"/>
+          <p:nvPr/>
+        </p:nvSpPr>
+        <p:spPr>
+          <a:xfrm>
+            <a:off x="6217920" y="2240280"/>
+            <a:ext cx="4663440" cy="3794760"/>
+          </a:xfrm>
+          <a:prstGeom prst="rect">
+            <a:avLst/>
+          </a:prstGeom>
+          <a:noFill/>
+        </p:spPr>
+        <p:txBody>
+          <a:bodyPr wrap="square">
+            <a:spAutoFit/>
+          </a:bodyPr>
+          <a:lstStyle/>
+          <a:p>
+            <a:pPr>
+              <a:spcAft>
+                <a:spcPts val="400"/>
+              </a:spcAft>
+              <a:defRPr sz="1300">
+                <a:solidFill>
+                  <a:srgbClr val="2B2B2B"/>
+                </a:solidFill>
+                <a:latin typeface="Calibri"/>
+              </a:defRPr>
+            </a:pPr>
+            <a:r>
+              <a:t>«As a senior project manager, draft a reply to this stakeholder. Propose a timeline.»</a:t>
+            </a:r>
+          </a:p>
+          <a:p>
+            <a:pPr>
+              <a:spcAft>
+                <a:spcPts val="400"/>
+              </a:spcAft>
+              <a:defRPr sz="1300">
+                <a:solidFill>
+                  <a:srgbClr val="2B2B2B"/>
+                </a:solidFill>
+                <a:latin typeface="Calibri"/>
+              </a:defRPr>
+            </a:pPr>
+          </a:p>
+          <a:p>
+            <a:pPr>
+              <a:spcAft>
+                <a:spcPts val="400"/>
+              </a:spcAft>
+              <a:defRPr sz="1300">
+                <a:solidFill>
+                  <a:srgbClr val="2B2B2B"/>
+                </a:solidFill>
+                <a:latin typeface="Calibri"/>
+              </a:defRPr>
+            </a:pPr>
+            <a:r>
               <a:t>→ Réponse ciblée, ton professionnel. Prêt à envoyer!</a:t>
+            </a:r>
+          </a:p>
+        </p:txBody>
+      </p:sp>
+      <p:sp>
+        <p:nvSpPr>
+          <p:cNvPr id="12" name="Rectangle 11"/>
+          <p:cNvSpPr/>
+          <p:nvPr/>
+        </p:nvSpPr>
+        <p:spPr>
+          <a:xfrm>
+            <a:off x="457200" y="6446520"/>
+            <a:ext cx="11274552" cy="13716"/>
+          </a:xfrm>
+          <a:prstGeom prst="rect">
+            <a:avLst/>
+          </a:prstGeom>
+          <a:solidFill>
+            <a:srgbClr val="00874E"/>
+          </a:solidFill>
+          <a:ln>
+            <a:noFill/>
+          </a:ln>
+          <a:effectLst/>
+        </p:spPr>
+        <p:style>
+          <a:lnRef idx="1">
+            <a:schemeClr val="accent1"/>
+          </a:lnRef>
+          <a:fillRef idx="3">
+            <a:schemeClr val="accent1"/>
+          </a:fillRef>
+          <a:effectRef idx="2">
+            <a:schemeClr val="accent1"/>
+          </a:effectRef>
+          <a:fontRef idx="minor">
+            <a:schemeClr val="lt1"/>
+          </a:fontRef>
+        </p:style>
+        <p:txBody>
+          <a:bodyPr rtlCol="0" anchor="ctr"/>
+          <a:lstStyle/>
+          <a:p>
+            <a:pPr algn="ctr"/>
+          </a:p>
+        </p:txBody>
+      </p:sp>
+      <p:sp>
+        <p:nvSpPr>
+          <p:cNvPr id="13" name="TextBox 12"/>
+          <p:cNvSpPr txBox="1"/>
+          <p:nvPr/>
+        </p:nvSpPr>
+        <p:spPr>
+          <a:xfrm>
+            <a:off x="457200" y="6537960"/>
+            <a:ext cx="5486400" cy="274320"/>
+          </a:xfrm>
+          <a:prstGeom prst="rect">
+            <a:avLst/>
+          </a:prstGeom>
+          <a:noFill/>
+        </p:spPr>
+        <p:txBody>
+          <a:bodyPr wrap="square" lIns="45720" rIns="45720" tIns="18288" bIns="18288">
+            <a:spAutoFit/>
+          </a:bodyPr>
+          <a:lstStyle/>
+          <a:p>
+            <a:pPr algn="l">
+              <a:defRPr sz="1000" b="0">
+                <a:solidFill>
+                  <a:srgbClr val="6B6B6B"/>
+                </a:solidFill>
+                <a:latin typeface="Calibri"/>
+              </a:defRPr>
+            </a:pPr>
+            <a:r>
+              <a:t>La minute Copilot</a:t>
+            </a:r>
+          </a:p>
+        </p:txBody>
+      </p:sp>
+      <p:sp>
+        <p:nvSpPr>
+          <p:cNvPr id="14" name="TextBox 13"/>
+          <p:cNvSpPr txBox="1"/>
+          <p:nvPr/>
+        </p:nvSpPr>
+        <p:spPr>
+          <a:xfrm>
+            <a:off x="10972800" y="6537960"/>
+            <a:ext cx="822960" cy="274320"/>
+          </a:xfrm>
+          <a:prstGeom prst="rect">
+            <a:avLst/>
+          </a:prstGeom>
+          <a:noFill/>
+        </p:spPr>
+        <p:txBody>
+          <a:bodyPr wrap="square" lIns="45720" rIns="45720" tIns="18288" bIns="18288">
+            <a:spAutoFit/>
+          </a:bodyPr>
+          <a:lstStyle/>
+          <a:p>
+            <a:pPr algn="r">
+              <a:defRPr sz="1000" b="0">
+                <a:solidFill>
+                  <a:srgbClr val="6B6B6B"/>
+                </a:solidFill>
+                <a:latin typeface="Calibri"/>
+              </a:defRPr>
+            </a:pPr>
+            <a:r>
+              <a:t>4</a:t>
             </a:r>
           </a:p>
         </p:txBody>
@@ -5452,7 +6195,7 @@
     <p:bg>
       <p:bgPr>
         <a:solidFill>
-          <a:srgbClr val="FFFFFF"/>
+          <a:srgbClr val="E6F0EA"/>
         </a:solidFill>
         <a:effectLst/>
       </p:bgPr>
@@ -5472,8 +6215,8 @@
         </p:nvSpPr>
         <p:spPr>
           <a:xfrm>
-            <a:off x="457200" y="274320"/>
-            <a:ext cx="10972800" cy="640080"/>
+            <a:off x="457200" y="365760"/>
+            <a:ext cx="10972800" cy="731520"/>
           </a:xfrm>
           <a:prstGeom prst="rect">
             <a:avLst/>
@@ -5481,21 +6224,21 @@
           <a:noFill/>
         </p:spPr>
         <p:txBody>
-          <a:bodyPr wrap="square">
+          <a:bodyPr wrap="square" lIns="45720" rIns="45720" tIns="18288" bIns="18288">
             <a:spAutoFit/>
           </a:bodyPr>
           <a:lstStyle/>
           <a:p>
             <a:pPr algn="l">
-              <a:defRPr sz="3200" b="1">
-                <a:solidFill>
-                  <a:srgbClr val="2B2B2B"/>
+              <a:defRPr sz="2800" b="1">
+                <a:solidFill>
+                  <a:srgbClr val="006B3F"/>
                 </a:solidFill>
                 <a:latin typeface="Calibri"/>
               </a:defRPr>
             </a:pPr>
             <a:r>
-              <a:t>📋 La recette: Persona + Contexte + Tâche + Format</a:t>
+              <a:t>La recette: Persona + Contexte + Tâche + Format</a:t>
             </a:r>
           </a:p>
         </p:txBody>
@@ -5508,8 +6251,8 @@
         </p:nvSpPr>
         <p:spPr>
           <a:xfrm>
-            <a:off x="457200" y="914400"/>
-            <a:ext cx="10972800" cy="457200"/>
+            <a:off x="457200" y="1005840"/>
+            <a:ext cx="10972800" cy="411480"/>
           </a:xfrm>
           <a:prstGeom prst="rect">
             <a:avLst/>
@@ -5517,13 +6260,13 @@
           <a:noFill/>
         </p:spPr>
         <p:txBody>
-          <a:bodyPr wrap="square">
+          <a:bodyPr wrap="square" lIns="45720" rIns="45720" tIns="18288" bIns="18288">
             <a:spAutoFit/>
           </a:bodyPr>
           <a:lstStyle/>
           <a:p>
             <a:pPr algn="l">
-              <a:defRPr sz="1800" b="0">
+              <a:defRPr sz="1500" b="0">
                 <a:solidFill>
                   <a:srgbClr val="6B6B6B"/>
                 </a:solidFill>
@@ -5538,113 +6281,25 @@
       </p:sp>
       <p:sp>
         <p:nvSpPr>
-          <p:cNvPr id="4" name="TextBox 3"/>
-          <p:cNvSpPr txBox="1"/>
-          <p:nvPr/>
-        </p:nvSpPr>
-        <p:spPr>
-          <a:xfrm>
-            <a:off x="457200" y="1554480"/>
-            <a:ext cx="10972800" cy="1371600"/>
-          </a:xfrm>
-          <a:prstGeom prst="rect">
-            <a:avLst/>
-          </a:prstGeom>
-          <a:noFill/>
-        </p:spPr>
-        <p:txBody>
-          <a:bodyPr wrap="square">
-            <a:spAutoFit/>
-          </a:bodyPr>
-          <a:lstStyle/>
-          <a:p>
-            <a:pPr>
-              <a:spcAft>
-                <a:spcPts val="400"/>
-              </a:spcAft>
-              <a:defRPr sz="1400">
-                <a:solidFill>
-                  <a:srgbClr val="2B2B2B"/>
-                </a:solidFill>
-                <a:latin typeface="Calibri"/>
-              </a:defRPr>
-            </a:pPr>
-            <a:r>
-              <a:t>• Persona: Qui es-tu? (chef de projet, développeur, formateur...)</a:t>
-            </a:r>
-          </a:p>
-          <a:p>
-            <a:pPr>
-              <a:spcAft>
-                <a:spcPts val="400"/>
-              </a:spcAft>
-              <a:defRPr sz="1400">
-                <a:solidFill>
-                  <a:srgbClr val="2B2B2B"/>
-                </a:solidFill>
-                <a:latin typeface="Calibri"/>
-              </a:defRPr>
-            </a:pPr>
-            <a:r>
-              <a:t>• Contexte: De quoi parlons-nous? (ce courriel, ce client...)</a:t>
-            </a:r>
-          </a:p>
-          <a:p>
-            <a:pPr>
-              <a:spcAft>
-                <a:spcPts val="400"/>
-              </a:spcAft>
-              <a:defRPr sz="1400">
-                <a:solidFill>
-                  <a:srgbClr val="2B2B2B"/>
-                </a:solidFill>
-                <a:latin typeface="Calibri"/>
-              </a:defRPr>
-            </a:pPr>
-            <a:r>
-              <a:t>• Tâche: Que veux-tu? (résumer, rédiger, analyser...)</a:t>
-            </a:r>
-          </a:p>
-          <a:p>
-            <a:pPr>
-              <a:spcAft>
-                <a:spcPts val="400"/>
-              </a:spcAft>
-              <a:defRPr sz="1400">
-                <a:solidFill>
-                  <a:srgbClr val="2B2B2B"/>
-                </a:solidFill>
-                <a:latin typeface="Calibri"/>
-              </a:defRPr>
-            </a:pPr>
-            <a:r>
-              <a:t>• Format: Comment? (3 puces, tableau, courriel formel...)</a:t>
-            </a:r>
-          </a:p>
-        </p:txBody>
-      </p:sp>
-      <p:sp>
-        <p:nvSpPr>
-          <p:cNvPr id="5" name="Rectangle 4"/>
+          <p:cNvPr id="4" name="Rectangle 3"/>
           <p:cNvSpPr/>
           <p:nvPr/>
         </p:nvSpPr>
         <p:spPr>
           <a:xfrm>
-            <a:off x="457200" y="3017520"/>
-            <a:ext cx="3383280" cy="3657600"/>
+            <a:off x="457200" y="1508760"/>
+            <a:ext cx="11274552" cy="18288"/>
           </a:xfrm>
           <a:prstGeom prst="rect">
             <a:avLst/>
           </a:prstGeom>
           <a:solidFill>
-            <a:srgbClr val="FFFFFF"/>
+            <a:srgbClr val="00874E"/>
           </a:solidFill>
           <a:ln>
-            <a:solidFill>
-              <a:srgbClr val="E0E0E0"/>
-            </a:solidFill>
+            <a:noFill/>
           </a:ln>
+          <a:effectLst/>
         </p:spPr>
         <p:style>
           <a:lnRef idx="1">
@@ -5670,50 +6325,14 @@
       </p:sp>
       <p:sp>
         <p:nvSpPr>
-          <p:cNvPr id="6" name="TextBox 5"/>
+          <p:cNvPr id="5" name="TextBox 4"/>
           <p:cNvSpPr txBox="1"/>
           <p:nvPr/>
         </p:nvSpPr>
         <p:spPr>
           <a:xfrm>
-            <a:off x="731520" y="3200400"/>
-            <a:ext cx="2834640" cy="457200"/>
-          </a:xfrm>
-          <a:prstGeom prst="rect">
-            <a:avLst/>
-          </a:prstGeom>
-          <a:noFill/>
-        </p:spPr>
-        <p:txBody>
-          <a:bodyPr wrap="square">
-            <a:spAutoFit/>
-          </a:bodyPr>
-          <a:lstStyle/>
-          <a:p>
-            <a:pPr algn="l">
-              <a:defRPr sz="1800" b="1">
-                <a:solidFill>
-                  <a:srgbClr val="0078D4"/>
-                </a:solidFill>
-                <a:latin typeface="Calibri"/>
-              </a:defRPr>
-            </a:pPr>
-            <a:r>
-              <a:t>📝 Template universel</a:t>
-            </a:r>
-          </a:p>
-        </p:txBody>
-      </p:sp>
-      <p:sp>
-        <p:nvSpPr>
-          <p:cNvPr id="7" name="TextBox 6"/>
-          <p:cNvSpPr txBox="1"/>
-          <p:nvPr/>
-        </p:nvSpPr>
-        <p:spPr>
-          <a:xfrm>
-            <a:off x="731520" y="3657600"/>
-            <a:ext cx="2834640" cy="2743200"/>
+            <a:off x="457200" y="1737360"/>
+            <a:ext cx="10972800" cy="1188720"/>
           </a:xfrm>
           <a:prstGeom prst="rect">
             <a:avLst/>
@@ -5730,7 +6349,7 @@
               <a:spcAft>
                 <a:spcPts val="400"/>
               </a:spcAft>
-              <a:defRPr sz="1300">
+              <a:defRPr sz="1400">
                 <a:solidFill>
                   <a:srgbClr val="2B2B2B"/>
                 </a:solidFill>
@@ -5738,21 +6357,69 @@
               </a:defRPr>
             </a:pPr>
             <a:r>
-              <a:t>«En tant que [persona], dans le contexte de [sujet], [action] en [format].»</a:t>
-            </a:r>
-          </a:p>
-        </p:txBody>
-      </p:sp>
-      <p:sp>
-        <p:nvSpPr>
-          <p:cNvPr id="8" name="Rectangle 7"/>
+              <a:t>• Persona: Qui es-tu? (chef de projet, développeur, formateur...)</a:t>
+            </a:r>
+          </a:p>
+          <a:p>
+            <a:pPr>
+              <a:spcAft>
+                <a:spcPts val="400"/>
+              </a:spcAft>
+              <a:defRPr sz="1400">
+                <a:solidFill>
+                  <a:srgbClr val="2B2B2B"/>
+                </a:solidFill>
+                <a:latin typeface="Calibri"/>
+              </a:defRPr>
+            </a:pPr>
+            <a:r>
+              <a:t>• Contexte: De quoi parlons-nous? (ce courriel, ce client...)</a:t>
+            </a:r>
+          </a:p>
+          <a:p>
+            <a:pPr>
+              <a:spcAft>
+                <a:spcPts val="400"/>
+              </a:spcAft>
+              <a:defRPr sz="1400">
+                <a:solidFill>
+                  <a:srgbClr val="2B2B2B"/>
+                </a:solidFill>
+                <a:latin typeface="Calibri"/>
+              </a:defRPr>
+            </a:pPr>
+            <a:r>
+              <a:t>• Tâche: Que veux-tu? (résumer, rédiger, analyser...)</a:t>
+            </a:r>
+          </a:p>
+          <a:p>
+            <a:pPr>
+              <a:spcAft>
+                <a:spcPts val="400"/>
+              </a:spcAft>
+              <a:defRPr sz="1400">
+                <a:solidFill>
+                  <a:srgbClr val="2B2B2B"/>
+                </a:solidFill>
+                <a:latin typeface="Calibri"/>
+              </a:defRPr>
+            </a:pPr>
+            <a:r>
+              <a:t>• Format: Comment? (3 puces, tableau, courriel formel...)</a:t>
+            </a:r>
+          </a:p>
+        </p:txBody>
+      </p:sp>
+      <p:sp>
+        <p:nvSpPr>
+          <p:cNvPr id="6" name="Rectangle 5"/>
           <p:cNvSpPr/>
           <p:nvPr/>
         </p:nvSpPr>
         <p:spPr>
           <a:xfrm>
-            <a:off x="4114800" y="3017520"/>
-            <a:ext cx="3383280" cy="3657600"/>
+            <a:off x="457200" y="2926080"/>
+            <a:ext cx="3383280" cy="3291840"/>
           </a:xfrm>
           <a:prstGeom prst="rect">
             <a:avLst/>
@@ -5765,6 +6432,7 @@
               <a:srgbClr val="E0E0E0"/>
             </a:solidFill>
           </a:ln>
+          <a:effectLst/>
         </p:spPr>
         <p:style>
           <a:lnRef idx="1">
@@ -5788,6 +6456,66 @@
           </a:p>
         </p:txBody>
       </p:sp>
+      <p:pic>
+        <p:nvPicPr>
+          <p:cNvPr id="7" name="Picture 6" descr="layout-template_00874E_30.png"/>
+          <p:cNvPicPr>
+            <a:picLocks noChangeAspect="1"/>
+          </p:cNvPicPr>
+          <p:nvPr/>
+        </p:nvPicPr>
+        <p:blipFill>
+          <a:blip r:embed="rId3"/>
+          <a:stretch>
+            <a:fillRect/>
+          </a:stretch>
+        </p:blipFill>
+        <p:spPr>
+          <a:xfrm>
+            <a:off x="713232" y="3090672"/>
+            <a:ext cx="292608" cy="292608"/>
+          </a:xfrm>
+          <a:prstGeom prst="rect">
+            <a:avLst/>
+          </a:prstGeom>
+        </p:spPr>
+      </p:pic>
+      <p:sp>
+        <p:nvSpPr>
+          <p:cNvPr id="8" name="TextBox 7"/>
+          <p:cNvSpPr txBox="1"/>
+          <p:nvPr/>
+        </p:nvSpPr>
+        <p:spPr>
+          <a:xfrm>
+            <a:off x="1115568" y="3108960"/>
+            <a:ext cx="2542032" cy="457200"/>
+          </a:xfrm>
+          <a:prstGeom prst="rect">
+            <a:avLst/>
+          </a:prstGeom>
+          <a:noFill/>
+        </p:spPr>
+        <p:txBody>
+          <a:bodyPr wrap="square" lIns="45720" rIns="45720" tIns="18288" bIns="18288">
+            <a:spAutoFit/>
+          </a:bodyPr>
+          <a:lstStyle/>
+          <a:p>
+            <a:pPr algn="l">
+              <a:defRPr sz="1700" b="1">
+                <a:solidFill>
+                  <a:srgbClr val="00874E"/>
+                </a:solidFill>
+                <a:latin typeface="Calibri"/>
+              </a:defRPr>
+            </a:pPr>
+            <a:r>
+              <a:t>Template universel</a:t>
+            </a:r>
+          </a:p>
+        </p:txBody>
+      </p:sp>
       <p:sp>
         <p:nvSpPr>
           <p:cNvPr id="9" name="TextBox 8"/>
@@ -5796,44 +6524,8 @@
         </p:nvSpPr>
         <p:spPr>
           <a:xfrm>
-            <a:off x="4389120" y="3200400"/>
-            <a:ext cx="2834640" cy="457200"/>
-          </a:xfrm>
-          <a:prstGeom prst="rect">
-            <a:avLst/>
-          </a:prstGeom>
-          <a:noFill/>
-        </p:spPr>
-        <p:txBody>
-          <a:bodyPr wrap="square">
-            <a:spAutoFit/>
-          </a:bodyPr>
-          <a:lstStyle/>
-          <a:p>
-            <a:pPr algn="l">
-              <a:defRPr sz="1800" b="1">
-                <a:solidFill>
-                  <a:srgbClr val="10B981"/>
-                </a:solidFill>
-                <a:latin typeface="Calibri"/>
-              </a:defRPr>
-            </a:pPr>
-            <a:r>
-              <a:t>💡 Exemple</a:t>
-            </a:r>
-          </a:p>
-        </p:txBody>
-      </p:sp>
-      <p:sp>
-        <p:nvSpPr>
-          <p:cNvPr id="10" name="TextBox 9"/>
-          <p:cNvSpPr txBox="1"/>
-          <p:nvPr/>
-        </p:nvSpPr>
-        <p:spPr>
-          <a:xfrm>
-            <a:off x="4389120" y="3657600"/>
-            <a:ext cx="2834640" cy="2743200"/>
+            <a:off x="731520" y="3703320"/>
+            <a:ext cx="2834640" cy="2331720"/>
           </a:xfrm>
           <a:prstGeom prst="rect">
             <a:avLst/>
@@ -5858,21 +6550,21 @@
               </a:defRPr>
             </a:pPr>
             <a:r>
-              <a:t>«En tant que chef de projet, dans le cadre du projet Alpha, résume l'avancement en 3 puces.»</a:t>
-            </a:r>
-          </a:p>
-        </p:txBody>
-      </p:sp>
-      <p:sp>
-        <p:nvSpPr>
-          <p:cNvPr id="11" name="Rectangle 10"/>
+              <a:t>«En tant que [persona], dans le contexte de [sujet], [action] en [format].»</a:t>
+            </a:r>
+          </a:p>
+        </p:txBody>
+      </p:sp>
+      <p:sp>
+        <p:nvSpPr>
+          <p:cNvPr id="10" name="Rectangle 9"/>
           <p:cNvSpPr/>
           <p:nvPr/>
         </p:nvSpPr>
         <p:spPr>
           <a:xfrm>
-            <a:off x="7772400" y="3017520"/>
-            <a:ext cx="3383280" cy="3657600"/>
+            <a:off x="4114800" y="2926080"/>
+            <a:ext cx="3383280" cy="3291840"/>
           </a:xfrm>
           <a:prstGeom prst="rect">
             <a:avLst/>
@@ -5885,6 +6577,7 @@
               <a:srgbClr val="E0E0E0"/>
             </a:solidFill>
           </a:ln>
+          <a:effectLst/>
         </p:spPr>
         <p:style>
           <a:lnRef idx="1">
@@ -5908,6 +6601,30 @@
           </a:p>
         </p:txBody>
       </p:sp>
+      <p:pic>
+        <p:nvPicPr>
+          <p:cNvPr id="11" name="Picture 10" descr="file-text_00874E_30.png"/>
+          <p:cNvPicPr>
+            <a:picLocks noChangeAspect="1"/>
+          </p:cNvPicPr>
+          <p:nvPr/>
+        </p:nvPicPr>
+        <p:blipFill>
+          <a:blip r:embed="rId4"/>
+          <a:stretch>
+            <a:fillRect/>
+          </a:stretch>
+        </p:blipFill>
+        <p:spPr>
+          <a:xfrm>
+            <a:off x="4370832" y="3090672"/>
+            <a:ext cx="292608" cy="292608"/>
+          </a:xfrm>
+          <a:prstGeom prst="rect">
+            <a:avLst/>
+          </a:prstGeom>
+        </p:spPr>
+      </p:pic>
       <p:sp>
         <p:nvSpPr>
           <p:cNvPr id="12" name="TextBox 11"/>
@@ -5916,8 +6633,8 @@
         </p:nvSpPr>
         <p:spPr>
           <a:xfrm>
-            <a:off x="8046720" y="3200400"/>
-            <a:ext cx="2834640" cy="457200"/>
+            <a:off x="4773168" y="3108960"/>
+            <a:ext cx="2542031" cy="457200"/>
           </a:xfrm>
           <a:prstGeom prst="rect">
             <a:avLst/>
@@ -5925,21 +6642,21 @@
           <a:noFill/>
         </p:spPr>
         <p:txBody>
-          <a:bodyPr wrap="square">
+          <a:bodyPr wrap="square" lIns="45720" rIns="45720" tIns="18288" bIns="18288">
             <a:spAutoFit/>
           </a:bodyPr>
           <a:lstStyle/>
           <a:p>
             <a:pPr algn="l">
-              <a:defRPr sz="1800" b="1">
-                <a:solidFill>
-                  <a:srgbClr val="F59E0B"/>
+              <a:defRPr sz="1700" b="1">
+                <a:solidFill>
+                  <a:srgbClr val="00874E"/>
                 </a:solidFill>
                 <a:latin typeface="Calibri"/>
               </a:defRPr>
             </a:pPr>
             <a:r>
-              <a:t>🏪 Sauvegarder</a:t>
+              <a:t>Exemple</a:t>
             </a:r>
           </a:p>
         </p:txBody>
@@ -5952,8 +6669,8 @@
         </p:nvSpPr>
         <p:spPr>
           <a:xfrm>
-            <a:off x="8046720" y="3657600"/>
-            <a:ext cx="2834640" cy="2743200"/>
+            <a:off x="4389120" y="3703320"/>
+            <a:ext cx="2834640" cy="2331720"/>
           </a:xfrm>
           <a:prstGeom prst="rect">
             <a:avLst/>
@@ -5978,9 +6695,138 @@
               </a:defRPr>
             </a:pPr>
             <a:r>
-              <a:t>Quick Parts: votre template</a:t>
-            </a:r>
-          </a:p>
+              <a:t>«En tant que chef de projet, dans le cadre du projet Alpha, résume l'avancement en 3 puces.»</a:t>
+            </a:r>
+          </a:p>
+        </p:txBody>
+      </p:sp>
+      <p:sp>
+        <p:nvSpPr>
+          <p:cNvPr id="14" name="Rectangle 13"/>
+          <p:cNvSpPr/>
+          <p:nvPr/>
+        </p:nvSpPr>
+        <p:spPr>
+          <a:xfrm>
+            <a:off x="7772400" y="2926080"/>
+            <a:ext cx="3383280" cy="3291840"/>
+          </a:xfrm>
+          <a:prstGeom prst="rect">
+            <a:avLst/>
+          </a:prstGeom>
+          <a:solidFill>
+            <a:srgbClr val="FFFFFF"/>
+          </a:solidFill>
+          <a:ln>
+            <a:solidFill>
+              <a:srgbClr val="E0E0E0"/>
+            </a:solidFill>
+          </a:ln>
+          <a:effectLst/>
+        </p:spPr>
+        <p:style>
+          <a:lnRef idx="1">
+            <a:schemeClr val="accent1"/>
+          </a:lnRef>
+          <a:fillRef idx="3">
+            <a:schemeClr val="accent1"/>
+          </a:fillRef>
+          <a:effectRef idx="2">
+            <a:schemeClr val="accent1"/>
+          </a:effectRef>
+          <a:fontRef idx="minor">
+            <a:schemeClr val="lt1"/>
+          </a:fontRef>
+        </p:style>
+        <p:txBody>
+          <a:bodyPr rtlCol="0" anchor="ctr"/>
+          <a:lstStyle/>
+          <a:p>
+            <a:pPr algn="ctr"/>
+          </a:p>
+        </p:txBody>
+      </p:sp>
+      <p:pic>
+        <p:nvPicPr>
+          <p:cNvPr id="15" name="Picture 14" descr="save_F59E0B_30.png"/>
+          <p:cNvPicPr>
+            <a:picLocks noChangeAspect="1"/>
+          </p:cNvPicPr>
+          <p:nvPr/>
+        </p:nvPicPr>
+        <p:blipFill>
+          <a:blip r:embed="rId5"/>
+          <a:stretch>
+            <a:fillRect/>
+          </a:stretch>
+        </p:blipFill>
+        <p:spPr>
+          <a:xfrm>
+            <a:off x="8028431" y="3090672"/>
+            <a:ext cx="292608" cy="292608"/>
+          </a:xfrm>
+          <a:prstGeom prst="rect">
+            <a:avLst/>
+          </a:prstGeom>
+        </p:spPr>
+      </p:pic>
+      <p:sp>
+        <p:nvSpPr>
+          <p:cNvPr id="16" name="TextBox 15"/>
+          <p:cNvSpPr txBox="1"/>
+          <p:nvPr/>
+        </p:nvSpPr>
+        <p:spPr>
+          <a:xfrm>
+            <a:off x="8430767" y="3108960"/>
+            <a:ext cx="2542032" cy="457200"/>
+          </a:xfrm>
+          <a:prstGeom prst="rect">
+            <a:avLst/>
+          </a:prstGeom>
+          <a:noFill/>
+        </p:spPr>
+        <p:txBody>
+          <a:bodyPr wrap="square" lIns="45720" rIns="45720" tIns="18288" bIns="18288">
+            <a:spAutoFit/>
+          </a:bodyPr>
+          <a:lstStyle/>
+          <a:p>
+            <a:pPr algn="l">
+              <a:defRPr sz="1700" b="1">
+                <a:solidFill>
+                  <a:srgbClr val="F59E0B"/>
+                </a:solidFill>
+                <a:latin typeface="Calibri"/>
+              </a:defRPr>
+            </a:pPr>
+            <a:r>
+              <a:t>Sauvegarder</a:t>
+            </a:r>
+          </a:p>
+        </p:txBody>
+      </p:sp>
+      <p:sp>
+        <p:nvSpPr>
+          <p:cNvPr id="17" name="TextBox 16"/>
+          <p:cNvSpPr txBox="1"/>
+          <p:nvPr/>
+        </p:nvSpPr>
+        <p:spPr>
+          <a:xfrm>
+            <a:off x="8046720" y="3703320"/>
+            <a:ext cx="2834640" cy="2331720"/>
+          </a:xfrm>
+          <a:prstGeom prst="rect">
+            <a:avLst/>
+          </a:prstGeom>
+          <a:noFill/>
+        </p:spPr>
+        <p:txBody>
+          <a:bodyPr wrap="square">
+            <a:spAutoFit/>
+          </a:bodyPr>
+          <a:lstStyle/>
           <a:p>
             <a:pPr>
               <a:spcAft>
@@ -5994,7 +6840,7 @@
               </a:defRPr>
             </a:pPr>
             <a:r>
-              <a:t>OneNote: vos personas préférés</a:t>
+              <a:t>Quick Parts: votre template</a:t>
             </a:r>
           </a:p>
           <a:p>
@@ -6010,7 +6856,139 @@
               </a:defRPr>
             </a:pPr>
             <a:r>
+              <a:t>OneNote: vos personas préférés</a:t>
+            </a:r>
+          </a:p>
+          <a:p>
+            <a:pPr>
+              <a:spcAft>
+                <a:spcPts val="400"/>
+              </a:spcAft>
+              <a:defRPr sz="1300">
+                <a:solidFill>
+                  <a:srgbClr val="2B2B2B"/>
+                </a:solidFill>
+                <a:latin typeface="Calibri"/>
+              </a:defRPr>
+            </a:pPr>
+            <a:r>
               <a:t>Copilot Lab: copilot.cloud.microsoft/prompts</a:t>
+            </a:r>
+          </a:p>
+        </p:txBody>
+      </p:sp>
+      <p:sp>
+        <p:nvSpPr>
+          <p:cNvPr id="18" name="Rectangle 17"/>
+          <p:cNvSpPr/>
+          <p:nvPr/>
+        </p:nvSpPr>
+        <p:spPr>
+          <a:xfrm>
+            <a:off x="457200" y="6446520"/>
+            <a:ext cx="11274552" cy="13716"/>
+          </a:xfrm>
+          <a:prstGeom prst="rect">
+            <a:avLst/>
+          </a:prstGeom>
+          <a:solidFill>
+            <a:srgbClr val="00874E"/>
+          </a:solidFill>
+          <a:ln>
+            <a:noFill/>
+          </a:ln>
+          <a:effectLst/>
+        </p:spPr>
+        <p:style>
+          <a:lnRef idx="1">
+            <a:schemeClr val="accent1"/>
+          </a:lnRef>
+          <a:fillRef idx="3">
+            <a:schemeClr val="accent1"/>
+          </a:fillRef>
+          <a:effectRef idx="2">
+            <a:schemeClr val="accent1"/>
+          </a:effectRef>
+          <a:fontRef idx="minor">
+            <a:schemeClr val="lt1"/>
+          </a:fontRef>
+        </p:style>
+        <p:txBody>
+          <a:bodyPr rtlCol="0" anchor="ctr"/>
+          <a:lstStyle/>
+          <a:p>
+            <a:pPr algn="ctr"/>
+          </a:p>
+        </p:txBody>
+      </p:sp>
+      <p:sp>
+        <p:nvSpPr>
+          <p:cNvPr id="19" name="TextBox 18"/>
+          <p:cNvSpPr txBox="1"/>
+          <p:nvPr/>
+        </p:nvSpPr>
+        <p:spPr>
+          <a:xfrm>
+            <a:off x="457200" y="6537960"/>
+            <a:ext cx="5486400" cy="274320"/>
+          </a:xfrm>
+          <a:prstGeom prst="rect">
+            <a:avLst/>
+          </a:prstGeom>
+          <a:noFill/>
+        </p:spPr>
+        <p:txBody>
+          <a:bodyPr wrap="square" lIns="45720" rIns="45720" tIns="18288" bIns="18288">
+            <a:spAutoFit/>
+          </a:bodyPr>
+          <a:lstStyle/>
+          <a:p>
+            <a:pPr algn="l">
+              <a:defRPr sz="1000" b="0">
+                <a:solidFill>
+                  <a:srgbClr val="6B6B6B"/>
+                </a:solidFill>
+                <a:latin typeface="Calibri"/>
+              </a:defRPr>
+            </a:pPr>
+            <a:r>
+              <a:t>La minute Copilot</a:t>
+            </a:r>
+          </a:p>
+        </p:txBody>
+      </p:sp>
+      <p:sp>
+        <p:nvSpPr>
+          <p:cNvPr id="20" name="TextBox 19"/>
+          <p:cNvSpPr txBox="1"/>
+          <p:nvPr/>
+        </p:nvSpPr>
+        <p:spPr>
+          <a:xfrm>
+            <a:off x="10972800" y="6537960"/>
+            <a:ext cx="822960" cy="274320"/>
+          </a:xfrm>
+          <a:prstGeom prst="rect">
+            <a:avLst/>
+          </a:prstGeom>
+          <a:noFill/>
+        </p:spPr>
+        <p:txBody>
+          <a:bodyPr wrap="square" lIns="45720" rIns="45720" tIns="18288" bIns="18288">
+            <a:spAutoFit/>
+          </a:bodyPr>
+          <a:lstStyle/>
+          <a:p>
+            <a:pPr algn="r">
+              <a:defRPr sz="1000" b="0">
+                <a:solidFill>
+                  <a:srgbClr val="6B6B6B"/>
+                </a:solidFill>
+                <a:latin typeface="Calibri"/>
+              </a:defRPr>
+            </a:pPr>
+            <a:r>
+              <a:t>5</a:t>
             </a:r>
           </a:p>
         </p:txBody>
@@ -6029,7 +7007,7 @@
     <p:bg>
       <p:bgPr>
         <a:solidFill>
-          <a:srgbClr val="0078D4"/>
+          <a:srgbClr val="00874E"/>
         </a:solidFill>
         <a:effectLst/>
       </p:bgPr>
@@ -6049,8 +7027,8 @@
         </p:nvSpPr>
         <p:spPr>
           <a:xfrm>
-            <a:off x="914400" y="914400"/>
-            <a:ext cx="10058400" cy="731520"/>
+            <a:off x="914400" y="731520"/>
+            <a:ext cx="10360152" cy="822960"/>
           </a:xfrm>
           <a:prstGeom prst="rect">
             <a:avLst/>
@@ -6058,13 +7036,13 @@
           <a:noFill/>
         </p:spPr>
         <p:txBody>
-          <a:bodyPr wrap="square">
+          <a:bodyPr wrap="square" lIns="45720" rIns="45720" tIns="18288" bIns="18288">
             <a:spAutoFit/>
           </a:bodyPr>
           <a:lstStyle/>
           <a:p>
             <a:pPr algn="ctr">
-              <a:defRPr sz="4000" b="1">
+              <a:defRPr sz="3600" b="1">
                 <a:solidFill>
                   <a:srgbClr val="FFFFFF"/>
                 </a:solidFill>
@@ -6072,7 +7050,7 @@
               </a:defRPr>
             </a:pPr>
             <a:r>
-              <a:t>🎭 À retenir</a:t>
+              <a:t>À retenir</a:t>
             </a:r>
           </a:p>
         </p:txBody>
@@ -6085,8 +7063,8 @@
         </p:nvSpPr>
         <p:spPr>
           <a:xfrm>
-            <a:off x="365760" y="2011680"/>
-            <a:ext cx="3474720" cy="2286000"/>
+            <a:off x="4572000" y="1691640"/>
+            <a:ext cx="3044952" cy="36576"/>
           </a:xfrm>
           <a:prstGeom prst="rect">
             <a:avLst/>
@@ -6095,10 +7073,9 @@
             <a:srgbClr val="FFFFFF"/>
           </a:solidFill>
           <a:ln>
-            <a:solidFill>
-              <a:srgbClr val="AAD4F0"/>
-            </a:solidFill>
+            <a:noFill/>
           </a:ln>
+          <a:effectLst/>
         </p:spPr>
         <p:style>
           <a:lnRef idx="1">
@@ -6124,86 +7101,14 @@
       </p:sp>
       <p:sp>
         <p:nvSpPr>
-          <p:cNvPr id="4" name="TextBox 3"/>
-          <p:cNvSpPr txBox="1"/>
-          <p:nvPr/>
-        </p:nvSpPr>
-        <p:spPr>
-          <a:xfrm>
-            <a:off x="640080" y="2194560"/>
-            <a:ext cx="2926079" cy="548640"/>
-          </a:xfrm>
-          <a:prstGeom prst="rect">
-            <a:avLst/>
-          </a:prstGeom>
-          <a:noFill/>
-        </p:spPr>
-        <p:txBody>
-          <a:bodyPr wrap="square">
-            <a:spAutoFit/>
-          </a:bodyPr>
-          <a:lstStyle/>
-          <a:p>
-            <a:pPr algn="ctr">
-              <a:defRPr sz="2200" b="1">
-                <a:solidFill>
-                  <a:srgbClr val="2B2B2B"/>
-                </a:solidFill>
-                <a:latin typeface="Calibri"/>
-              </a:defRPr>
-            </a:pPr>
-            <a:r>
-              <a:t>🎭 1. Persona</a:t>
-            </a:r>
-          </a:p>
-        </p:txBody>
-      </p:sp>
-      <p:sp>
-        <p:nvSpPr>
-          <p:cNvPr id="5" name="TextBox 4"/>
-          <p:cNvSpPr txBox="1"/>
-          <p:nvPr/>
-        </p:nvSpPr>
-        <p:spPr>
-          <a:xfrm>
-            <a:off x="640080" y="2926080"/>
-            <a:ext cx="2926079" cy="914400"/>
-          </a:xfrm>
-          <a:prstGeom prst="rect">
-            <a:avLst/>
-          </a:prstGeom>
-          <a:noFill/>
-        </p:spPr>
-        <p:txBody>
-          <a:bodyPr wrap="square">
-            <a:spAutoFit/>
-          </a:bodyPr>
-          <a:lstStyle/>
-          <a:p>
-            <a:pPr algn="ctr">
-              <a:defRPr sz="1600" b="0">
-                <a:solidFill>
-                  <a:srgbClr val="6B6B6B"/>
-                </a:solidFill>
-                <a:latin typeface="Calibri"/>
-              </a:defRPr>
-            </a:pPr>
-            <a:r>
-              <a:t>Donnez un rôle à Copilot</a:t>
-            </a:r>
-          </a:p>
-        </p:txBody>
-      </p:sp>
-      <p:sp>
-        <p:nvSpPr>
-          <p:cNvPr id="6" name="Rectangle 5"/>
+          <p:cNvPr id="4" name="Rectangle 3"/>
           <p:cNvSpPr/>
           <p:nvPr/>
         </p:nvSpPr>
         <p:spPr>
           <a:xfrm>
-            <a:off x="3749040" y="2011680"/>
-            <a:ext cx="3474720" cy="2286000"/>
+            <a:off x="806957" y="2103120"/>
+            <a:ext cx="3291840" cy="2286000"/>
           </a:xfrm>
           <a:prstGeom prst="rect">
             <a:avLst/>
@@ -6213,9 +7118,10 @@
           </a:solidFill>
           <a:ln>
             <a:solidFill>
-              <a:srgbClr val="AAD4F0"/>
+              <a:srgbClr val="CCE0D2"/>
             </a:solidFill>
           </a:ln>
+          <a:effectLst/>
         </p:spPr>
         <p:style>
           <a:lnRef idx="1">
@@ -6239,6 +7145,66 @@
           </a:p>
         </p:txBody>
       </p:sp>
+      <p:pic>
+        <p:nvPicPr>
+          <p:cNvPr id="5" name="Picture 4" descr="user_006B3F_36.png"/>
+          <p:cNvPicPr>
+            <a:picLocks noChangeAspect="1"/>
+          </p:cNvPicPr>
+          <p:nvPr/>
+        </p:nvPicPr>
+        <p:blipFill>
+          <a:blip r:embed="rId3"/>
+          <a:stretch>
+            <a:fillRect/>
+          </a:stretch>
+        </p:blipFill>
+        <p:spPr>
+          <a:xfrm>
+            <a:off x="2279141" y="2176272"/>
+            <a:ext cx="347472" cy="347472"/>
+          </a:xfrm>
+          <a:prstGeom prst="rect">
+            <a:avLst/>
+          </a:prstGeom>
+        </p:spPr>
+      </p:pic>
+      <p:sp>
+        <p:nvSpPr>
+          <p:cNvPr id="6" name="TextBox 5"/>
+          <p:cNvSpPr txBox="1"/>
+          <p:nvPr/>
+        </p:nvSpPr>
+        <p:spPr>
+          <a:xfrm>
+            <a:off x="944117" y="2596896"/>
+            <a:ext cx="3017520" cy="548640"/>
+          </a:xfrm>
+          <a:prstGeom prst="rect">
+            <a:avLst/>
+          </a:prstGeom>
+          <a:noFill/>
+        </p:spPr>
+        <p:txBody>
+          <a:bodyPr wrap="square" lIns="45720" rIns="45720" tIns="18288" bIns="18288">
+            <a:spAutoFit/>
+          </a:bodyPr>
+          <a:lstStyle/>
+          <a:p>
+            <a:pPr algn="ctr">
+              <a:defRPr sz="2200" b="1">
+                <a:solidFill>
+                  <a:srgbClr val="006B3F"/>
+                </a:solidFill>
+                <a:latin typeface="Calibri"/>
+              </a:defRPr>
+            </a:pPr>
+            <a:r>
+              <a:t>1. Persona</a:t>
+            </a:r>
+          </a:p>
+        </p:txBody>
+      </p:sp>
       <p:sp>
         <p:nvSpPr>
           <p:cNvPr id="7" name="TextBox 6"/>
@@ -6247,8 +7213,8 @@
         </p:nvSpPr>
         <p:spPr>
           <a:xfrm>
-            <a:off x="4023360" y="2194560"/>
-            <a:ext cx="2926079" cy="548640"/>
+            <a:off x="944117" y="3236976"/>
+            <a:ext cx="3017520" cy="914400"/>
           </a:xfrm>
           <a:prstGeom prst="rect">
             <a:avLst/>
@@ -6256,71 +7222,35 @@
           <a:noFill/>
         </p:spPr>
         <p:txBody>
-          <a:bodyPr wrap="square">
+          <a:bodyPr wrap="square" lIns="45720" rIns="45720" tIns="18288" bIns="18288">
             <a:spAutoFit/>
           </a:bodyPr>
           <a:lstStyle/>
           <a:p>
             <a:pPr algn="ctr">
-              <a:defRPr sz="2200" b="1">
-                <a:solidFill>
-                  <a:srgbClr val="2B2B2B"/>
+              <a:defRPr sz="1500" b="0">
+                <a:solidFill>
+                  <a:srgbClr val="6B6B6B"/>
                 </a:solidFill>
                 <a:latin typeface="Calibri"/>
               </a:defRPr>
             </a:pPr>
             <a:r>
-              <a:t>📝 2. Structure</a:t>
-            </a:r>
-          </a:p>
-        </p:txBody>
-      </p:sp>
-      <p:sp>
-        <p:nvSpPr>
-          <p:cNvPr id="8" name="TextBox 7"/>
-          <p:cNvSpPr txBox="1"/>
-          <p:nvPr/>
-        </p:nvSpPr>
-        <p:spPr>
-          <a:xfrm>
-            <a:off x="4023360" y="2926080"/>
-            <a:ext cx="2926079" cy="914400"/>
-          </a:xfrm>
-          <a:prstGeom prst="rect">
-            <a:avLst/>
-          </a:prstGeom>
-          <a:noFill/>
-        </p:spPr>
-        <p:txBody>
-          <a:bodyPr wrap="square">
-            <a:spAutoFit/>
-          </a:bodyPr>
-          <a:lstStyle/>
-          <a:p>
-            <a:pPr algn="ctr">
-              <a:defRPr sz="1600" b="0">
-                <a:solidFill>
-                  <a:srgbClr val="6B6B6B"/>
-                </a:solidFill>
-                <a:latin typeface="Calibri"/>
-              </a:defRPr>
-            </a:pPr>
-            <a:r>
-              <a:t>Persona + Contexte + Tâche + Format</a:t>
-            </a:r>
-          </a:p>
-        </p:txBody>
-      </p:sp>
-      <p:sp>
-        <p:nvSpPr>
-          <p:cNvPr id="9" name="Rectangle 8"/>
+              <a:t>Donnez un rôle à Copilot</a:t>
+            </a:r>
+          </a:p>
+        </p:txBody>
+      </p:sp>
+      <p:sp>
+        <p:nvSpPr>
+          <p:cNvPr id="8" name="Rectangle 7"/>
           <p:cNvSpPr/>
           <p:nvPr/>
         </p:nvSpPr>
         <p:spPr>
           <a:xfrm>
-            <a:off x="7132320" y="2011680"/>
-            <a:ext cx="3474720" cy="2286000"/>
+            <a:off x="4448556" y="2103120"/>
+            <a:ext cx="3291840" cy="2286000"/>
           </a:xfrm>
           <a:prstGeom prst="rect">
             <a:avLst/>
@@ -6330,9 +7260,10 @@
           </a:solidFill>
           <a:ln>
             <a:solidFill>
-              <a:srgbClr val="AAD4F0"/>
+              <a:srgbClr val="CCE0D2"/>
             </a:solidFill>
           </a:ln>
+          <a:effectLst/>
         </p:spPr>
         <p:style>
           <a:lnRef idx="1">
@@ -6356,6 +7287,30 @@
           </a:p>
         </p:txBody>
       </p:sp>
+      <p:pic>
+        <p:nvPicPr>
+          <p:cNvPr id="9" name="Picture 8" descr="list-tree_006B3F_36.png"/>
+          <p:cNvPicPr>
+            <a:picLocks noChangeAspect="1"/>
+          </p:cNvPicPr>
+          <p:nvPr/>
+        </p:nvPicPr>
+        <p:blipFill>
+          <a:blip r:embed="rId4"/>
+          <a:stretch>
+            <a:fillRect/>
+          </a:stretch>
+        </p:blipFill>
+        <p:spPr>
+          <a:xfrm>
+            <a:off x="5920740" y="2176272"/>
+            <a:ext cx="347472" cy="347472"/>
+          </a:xfrm>
+          <a:prstGeom prst="rect">
+            <a:avLst/>
+          </a:prstGeom>
+        </p:spPr>
+      </p:pic>
       <p:sp>
         <p:nvSpPr>
           <p:cNvPr id="10" name="TextBox 9"/>
@@ -6364,8 +7319,8 @@
         </p:nvSpPr>
         <p:spPr>
           <a:xfrm>
-            <a:off x="7406640" y="2194560"/>
-            <a:ext cx="2926079" cy="548640"/>
+            <a:off x="4585716" y="2596896"/>
+            <a:ext cx="3017520" cy="548640"/>
           </a:xfrm>
           <a:prstGeom prst="rect">
             <a:avLst/>
@@ -6373,7 +7328,7 @@
           <a:noFill/>
         </p:spPr>
         <p:txBody>
-          <a:bodyPr wrap="square">
+          <a:bodyPr wrap="square" lIns="45720" rIns="45720" tIns="18288" bIns="18288">
             <a:spAutoFit/>
           </a:bodyPr>
           <a:lstStyle/>
@@ -6381,13 +7336,13 @@
             <a:pPr algn="ctr">
               <a:defRPr sz="2200" b="1">
                 <a:solidFill>
-                  <a:srgbClr val="2B2B2B"/>
+                  <a:srgbClr val="006B3F"/>
                 </a:solidFill>
                 <a:latin typeface="Calibri"/>
               </a:defRPr>
             </a:pPr>
             <a:r>
-              <a:t>💾 3. Sauvegardez</a:t>
+              <a:t>2. Structure</a:t>
             </a:r>
           </a:p>
         </p:txBody>
@@ -6400,8 +7355,8 @@
         </p:nvSpPr>
         <p:spPr>
           <a:xfrm>
-            <a:off x="7406640" y="2926080"/>
-            <a:ext cx="2926079" cy="914400"/>
+            <a:off x="4585716" y="3236976"/>
+            <a:ext cx="3017520" cy="914400"/>
           </a:xfrm>
           <a:prstGeom prst="rect">
             <a:avLst/>
@@ -6409,13 +7364,13 @@
           <a:noFill/>
         </p:spPr>
         <p:txBody>
-          <a:bodyPr wrap="square">
+          <a:bodyPr wrap="square" lIns="45720" rIns="45720" tIns="18288" bIns="18288">
             <a:spAutoFit/>
           </a:bodyPr>
           <a:lstStyle/>
           <a:p>
             <a:pPr algn="ctr">
-              <a:defRPr sz="1600" b="0">
+              <a:defRPr sz="1500" b="0">
                 <a:solidFill>
                   <a:srgbClr val="6B6B6B"/>
                 </a:solidFill>
@@ -6423,7 +7378,7 @@
               </a:defRPr>
             </a:pPr>
             <a:r>
-              <a:t>Quick Parts pour vos prompts</a:t>
+              <a:t>Persona + Contexte + Tâche + Format</a:t>
             </a:r>
           </a:p>
         </p:txBody>
@@ -6436,20 +7391,21 @@
         </p:nvSpPr>
         <p:spPr>
           <a:xfrm>
-            <a:off x="3200400" y="4754880"/>
-            <a:ext cx="5760720" cy="1097280"/>
+            <a:off x="8090154" y="2103120"/>
+            <a:ext cx="3291840" cy="2286000"/>
           </a:xfrm>
           <a:prstGeom prst="rect">
             <a:avLst/>
           </a:prstGeom>
           <a:solidFill>
-            <a:srgbClr val="FFF3CD"/>
+            <a:srgbClr val="FFFFFF"/>
           </a:solidFill>
           <a:ln>
             <a:solidFill>
-              <a:srgbClr val="FFE082"/>
+              <a:srgbClr val="CCE0D2"/>
             </a:solidFill>
           </a:ln>
+          <a:effectLst/>
         </p:spPr>
         <p:style>
           <a:lnRef idx="1">
@@ -6473,16 +7429,40 @@
           </a:p>
         </p:txBody>
       </p:sp>
-      <p:sp>
-        <p:nvSpPr>
-          <p:cNvPr id="13" name="TextBox 12"/>
+      <p:pic>
+        <p:nvPicPr>
+          <p:cNvPr id="13" name="Picture 12" descr="bookmark_006B3F_36.png"/>
+          <p:cNvPicPr>
+            <a:picLocks noChangeAspect="1"/>
+          </p:cNvPicPr>
+          <p:nvPr/>
+        </p:nvPicPr>
+        <p:blipFill>
+          <a:blip r:embed="rId5"/>
+          <a:stretch>
+            <a:fillRect/>
+          </a:stretch>
+        </p:blipFill>
+        <p:spPr>
+          <a:xfrm>
+            <a:off x="9562338" y="2176272"/>
+            <a:ext cx="347472" cy="347472"/>
+          </a:xfrm>
+          <a:prstGeom prst="rect">
+            <a:avLst/>
+          </a:prstGeom>
+        </p:spPr>
+      </p:pic>
+      <p:sp>
+        <p:nvSpPr>
+          <p:cNvPr id="14" name="TextBox 13"/>
           <p:cNvSpPr txBox="1"/>
           <p:nvPr/>
         </p:nvSpPr>
         <p:spPr>
           <a:xfrm>
-            <a:off x="3383280" y="4937760"/>
-            <a:ext cx="5394960" cy="548640"/>
+            <a:off x="8227314" y="2596896"/>
+            <a:ext cx="3017520" cy="548640"/>
           </a:xfrm>
           <a:prstGeom prst="rect">
             <a:avLst/>
@@ -6490,35 +7470,35 @@
           <a:noFill/>
         </p:spPr>
         <p:txBody>
-          <a:bodyPr wrap="square">
+          <a:bodyPr wrap="square" lIns="45720" rIns="45720" tIns="18288" bIns="18288">
             <a:spAutoFit/>
           </a:bodyPr>
           <a:lstStyle/>
           <a:p>
             <a:pPr algn="ctr">
-              <a:defRPr sz="1600" b="1">
-                <a:solidFill>
-                  <a:srgbClr val="856E04"/>
+              <a:defRPr sz="2200" b="1">
+                <a:solidFill>
+                  <a:srgbClr val="006B3F"/>
                 </a:solidFill>
                 <a:latin typeface="Calibri"/>
               </a:defRPr>
             </a:pPr>
             <a:r>
-              <a:t>🎯 Défi: Ajoutez un persona à TOUS vos prompts cette semaine!</a:t>
-            </a:r>
-          </a:p>
-        </p:txBody>
-      </p:sp>
-      <p:sp>
-        <p:nvSpPr>
-          <p:cNvPr id="14" name="TextBox 13"/>
+              <a:t>3. Sauvegardez</a:t>
+            </a:r>
+          </a:p>
+        </p:txBody>
+      </p:sp>
+      <p:sp>
+        <p:nvSpPr>
+          <p:cNvPr id="15" name="TextBox 14"/>
           <p:cNvSpPr txBox="1"/>
           <p:nvPr/>
         </p:nvSpPr>
         <p:spPr>
           <a:xfrm>
-            <a:off x="914400" y="6126480"/>
-            <a:ext cx="10058400" cy="457200"/>
+            <a:off x="8227314" y="3236976"/>
+            <a:ext cx="3017520" cy="914400"/>
           </a:xfrm>
           <a:prstGeom prst="rect">
             <a:avLst/>
@@ -6526,21 +7506,183 @@
           <a:noFill/>
         </p:spPr>
         <p:txBody>
-          <a:bodyPr wrap="square">
+          <a:bodyPr wrap="square" lIns="45720" rIns="45720" tIns="18288" bIns="18288">
             <a:spAutoFit/>
           </a:bodyPr>
           <a:lstStyle/>
           <a:p>
             <a:pPr algn="ctr">
-              <a:defRPr sz="1400" b="0">
-                <a:solidFill>
-                  <a:srgbClr val="AAD4F0"/>
+              <a:defRPr sz="1500" b="0">
+                <a:solidFill>
+                  <a:srgbClr val="6B6B6B"/>
                 </a:solidFill>
                 <a:latin typeface="Calibri"/>
               </a:defRPr>
             </a:pPr>
             <a:r>
-              <a:t>La minute Copilot — À la semaine prochaine! 👋</a:t>
+              <a:t>Quick Parts pour vos prompts</a:t>
+            </a:r>
+          </a:p>
+        </p:txBody>
+      </p:sp>
+      <p:sp>
+        <p:nvSpPr>
+          <p:cNvPr id="16" name="Rectangle 15"/>
+          <p:cNvSpPr/>
+          <p:nvPr/>
+        </p:nvSpPr>
+        <p:spPr>
+          <a:xfrm>
+            <a:off x="2423160" y="4681728"/>
+            <a:ext cx="7342631" cy="1078992"/>
+          </a:xfrm>
+          <a:prstGeom prst="rect">
+            <a:avLst/>
+          </a:prstGeom>
+          <a:solidFill>
+            <a:srgbClr val="FFFFFF"/>
+          </a:solidFill>
+          <a:ln>
+            <a:solidFill>
+              <a:srgbClr val="CCE0D2"/>
+            </a:solidFill>
+          </a:ln>
+          <a:effectLst/>
+        </p:spPr>
+        <p:style>
+          <a:lnRef idx="1">
+            <a:schemeClr val="accent1"/>
+          </a:lnRef>
+          <a:fillRef idx="3">
+            <a:schemeClr val="accent1"/>
+          </a:fillRef>
+          <a:effectRef idx="2">
+            <a:schemeClr val="accent1"/>
+          </a:effectRef>
+          <a:fontRef idx="minor">
+            <a:schemeClr val="lt1"/>
+          </a:fontRef>
+        </p:style>
+        <p:txBody>
+          <a:bodyPr rtlCol="0" anchor="ctr"/>
+          <a:lstStyle/>
+          <a:p>
+            <a:pPr algn="ctr"/>
+          </a:p>
+        </p:txBody>
+      </p:sp>
+      <p:sp>
+        <p:nvSpPr>
+          <p:cNvPr id="17" name="Rectangle 16"/>
+          <p:cNvSpPr/>
+          <p:nvPr/>
+        </p:nvSpPr>
+        <p:spPr>
+          <a:xfrm>
+            <a:off x="2423160" y="4681728"/>
+            <a:ext cx="64008" cy="1078992"/>
+          </a:xfrm>
+          <a:prstGeom prst="rect">
+            <a:avLst/>
+          </a:prstGeom>
+          <a:solidFill>
+            <a:srgbClr val="00874E"/>
+          </a:solidFill>
+          <a:ln>
+            <a:noFill/>
+          </a:ln>
+          <a:effectLst/>
+        </p:spPr>
+        <p:style>
+          <a:lnRef idx="1">
+            <a:schemeClr val="accent1"/>
+          </a:lnRef>
+          <a:fillRef idx="3">
+            <a:schemeClr val="accent1"/>
+          </a:fillRef>
+          <a:effectRef idx="2">
+            <a:schemeClr val="accent1"/>
+          </a:effectRef>
+          <a:fontRef idx="minor">
+            <a:schemeClr val="lt1"/>
+          </a:fontRef>
+        </p:style>
+        <p:txBody>
+          <a:bodyPr rtlCol="0" anchor="ctr"/>
+          <a:lstStyle/>
+          <a:p>
+            <a:pPr algn="ctr"/>
+          </a:p>
+        </p:txBody>
+      </p:sp>
+      <p:sp>
+        <p:nvSpPr>
+          <p:cNvPr id="18" name="TextBox 17"/>
+          <p:cNvSpPr txBox="1"/>
+          <p:nvPr/>
+        </p:nvSpPr>
+        <p:spPr>
+          <a:xfrm>
+            <a:off x="2587752" y="4937760"/>
+            <a:ext cx="7013447" cy="713231"/>
+          </a:xfrm>
+          <a:prstGeom prst="rect">
+            <a:avLst/>
+          </a:prstGeom>
+          <a:noFill/>
+        </p:spPr>
+        <p:txBody>
+          <a:bodyPr wrap="square" lIns="45720" rIns="45720" tIns="18288" bIns="18288">
+            <a:spAutoFit/>
+          </a:bodyPr>
+          <a:lstStyle/>
+          <a:p>
+            <a:pPr algn="ctr">
+              <a:defRPr sz="1500" b="1">
+                <a:solidFill>
+                  <a:srgbClr val="006B3F"/>
+                </a:solidFill>
+                <a:latin typeface="Calibri"/>
+              </a:defRPr>
+            </a:pPr>
+            <a:r>
+              <a:t>Défi: Ajoutez un persona à TOUS vos prompts cette semaine!</a:t>
+            </a:r>
+          </a:p>
+        </p:txBody>
+      </p:sp>
+      <p:sp>
+        <p:nvSpPr>
+          <p:cNvPr id="19" name="TextBox 18"/>
+          <p:cNvSpPr txBox="1"/>
+          <p:nvPr/>
+        </p:nvSpPr>
+        <p:spPr>
+          <a:xfrm>
+            <a:off x="914400" y="5989320"/>
+            <a:ext cx="10360152" cy="365760"/>
+          </a:xfrm>
+          <a:prstGeom prst="rect">
+            <a:avLst/>
+          </a:prstGeom>
+          <a:noFill/>
+        </p:spPr>
+        <p:txBody>
+          <a:bodyPr wrap="square" lIns="45720" rIns="45720" tIns="18288" bIns="18288">
+            <a:spAutoFit/>
+          </a:bodyPr>
+          <a:lstStyle/>
+          <a:p>
+            <a:pPr algn="ctr">
+              <a:defRPr sz="1300" b="0">
+                <a:solidFill>
+                  <a:srgbClr val="CCE0D2"/>
+                </a:solidFill>
+                <a:latin typeface="Calibri"/>
+              </a:defRPr>
+            </a:pPr>
+            <a:r>
+              <a:t>La minute Copilot — À la semaine prochaine!</a:t>
             </a:r>
           </a:p>
         </p:txBody>

</xml_diff>